<commit_message>
Add how-it-works and project-role cue cards to concept slides
</commit_message>
<xml_diff>
--- a/final/SUNUM_FINAL.pptx
+++ b/final/SUNUM_FINAL.pptx
@@ -3806,8 +3806,8 @@
         </p:blipFill>
         <p:spPr>
           <a:xfrm>
-            <a:off x="1523847" y="1554480"/>
-            <a:ext cx="9144000" cy="3657600"/>
+            <a:off x="1752447" y="1417320"/>
+            <a:ext cx="8686800" cy="3474720"/>
           </a:xfrm>
           <a:prstGeom prst="rect">
             <a:avLst/>
@@ -3816,7 +3816,297 @@
       </p:pic>
       <p:sp>
         <p:nvSpPr>
-          <p:cNvPr id="6" name="Rectangle 5"/>
+          <p:cNvPr id="6" name="Rounded Rectangle 5"/>
+          <p:cNvSpPr/>
+          <p:nvPr/>
+        </p:nvSpPr>
+        <p:spPr>
+          <a:xfrm>
+            <a:off x="548640" y="5577840"/>
+            <a:ext cx="5440680" cy="777240"/>
+          </a:xfrm>
+          <a:prstGeom prst="roundRect">
+            <a:avLst>
+              <a:gd name="adj" fmla="val 8000"/>
+            </a:avLst>
+          </a:prstGeom>
+          <a:solidFill>
+            <a:srgbClr val="E8F1FA"/>
+          </a:solidFill>
+          <a:ln>
+            <a:noFill/>
+          </a:ln>
+          <a:effectLst/>
+        </p:spPr>
+        <p:style>
+          <a:lnRef idx="1">
+            <a:schemeClr val="accent1"/>
+          </a:lnRef>
+          <a:fillRef idx="3">
+            <a:schemeClr val="accent1"/>
+          </a:fillRef>
+          <a:effectRef idx="2">
+            <a:schemeClr val="accent1"/>
+          </a:effectRef>
+          <a:fontRef idx="minor">
+            <a:schemeClr val="lt1"/>
+          </a:fontRef>
+        </p:style>
+        <p:txBody>
+          <a:bodyPr rtlCol="0" anchor="ctr"/>
+          <a:lstStyle/>
+          <a:p>
+            <a:pPr algn="ctr"/>
+          </a:p>
+        </p:txBody>
+      </p:sp>
+      <p:sp>
+        <p:nvSpPr>
+          <p:cNvPr id="7" name="Rectangle 6"/>
+          <p:cNvSpPr/>
+          <p:nvPr/>
+        </p:nvSpPr>
+        <p:spPr>
+          <a:xfrm>
+            <a:off x="548640" y="5577840"/>
+            <a:ext cx="82296" cy="777240"/>
+          </a:xfrm>
+          <a:prstGeom prst="rect">
+            <a:avLst/>
+          </a:prstGeom>
+          <a:solidFill>
+            <a:srgbClr val="2F74C0"/>
+          </a:solidFill>
+          <a:ln>
+            <a:noFill/>
+          </a:ln>
+          <a:effectLst/>
+        </p:spPr>
+        <p:style>
+          <a:lnRef idx="1">
+            <a:schemeClr val="accent1"/>
+          </a:lnRef>
+          <a:fillRef idx="3">
+            <a:schemeClr val="accent1"/>
+          </a:fillRef>
+          <a:effectRef idx="2">
+            <a:schemeClr val="accent1"/>
+          </a:effectRef>
+          <a:fontRef idx="minor">
+            <a:schemeClr val="lt1"/>
+          </a:fontRef>
+        </p:style>
+        <p:txBody>
+          <a:bodyPr rtlCol="0" anchor="ctr"/>
+          <a:lstStyle/>
+          <a:p>
+            <a:pPr algn="ctr"/>
+          </a:p>
+        </p:txBody>
+      </p:sp>
+      <p:sp>
+        <p:nvSpPr>
+          <p:cNvPr id="8" name="TextBox 7"/>
+          <p:cNvSpPr txBox="1"/>
+          <p:nvPr/>
+        </p:nvSpPr>
+        <p:spPr>
+          <a:xfrm>
+            <a:off x="777240" y="5632704"/>
+            <a:ext cx="5120640" cy="658368"/>
+          </a:xfrm>
+          <a:prstGeom prst="rect">
+            <a:avLst/>
+          </a:prstGeom>
+          <a:noFill/>
+        </p:spPr>
+        <p:txBody>
+          <a:bodyPr wrap="square" anchor="t">
+            <a:spAutoFit/>
+          </a:bodyPr>
+          <a:lstStyle/>
+          <a:p>
+            <a:pPr algn="l">
+              <a:spcAft>
+                <a:spcPts val="400"/>
+              </a:spcAft>
+            </a:pPr>
+            <a:r>
+              <a:rPr sz="1050" b="1" i="0">
+                <a:solidFill>
+                  <a:srgbClr val="2F74C0"/>
+                </a:solidFill>
+                <a:latin typeface="Segoe UI"/>
+              </a:rPr>
+              <a:t>⚙ NASIL ÇALIŞIR</a:t>
+            </a:r>
+          </a:p>
+          <a:p>
+            <a:pPr algn="l">
+              <a:spcAft>
+                <a:spcPts val="400"/>
+              </a:spcAft>
+            </a:pPr>
+            <a:r>
+              <a:rPr sz="1300" b="1" i="0">
+                <a:solidFill>
+                  <a:srgbClr val="1F3B57"/>
+                </a:solidFill>
+                <a:latin typeface="Segoe UI"/>
+              </a:rPr>
+              <a:t>Her bölgeden EN BÜYÜĞÜ al</a:t>
+            </a:r>
+          </a:p>
+        </p:txBody>
+      </p:sp>
+      <p:sp>
+        <p:nvSpPr>
+          <p:cNvPr id="9" name="Rounded Rectangle 8"/>
+          <p:cNvSpPr/>
+          <p:nvPr/>
+        </p:nvSpPr>
+        <p:spPr>
+          <a:xfrm>
+            <a:off x="6199632" y="5577840"/>
+            <a:ext cx="5440680" cy="777240"/>
+          </a:xfrm>
+          <a:prstGeom prst="roundRect">
+            <a:avLst>
+              <a:gd name="adj" fmla="val 8000"/>
+            </a:avLst>
+          </a:prstGeom>
+          <a:solidFill>
+            <a:srgbClr val="E9F6EF"/>
+          </a:solidFill>
+          <a:ln>
+            <a:noFill/>
+          </a:ln>
+          <a:effectLst/>
+        </p:spPr>
+        <p:style>
+          <a:lnRef idx="1">
+            <a:schemeClr val="accent1"/>
+          </a:lnRef>
+          <a:fillRef idx="3">
+            <a:schemeClr val="accent1"/>
+          </a:fillRef>
+          <a:effectRef idx="2">
+            <a:schemeClr val="accent1"/>
+          </a:effectRef>
+          <a:fontRef idx="minor">
+            <a:schemeClr val="lt1"/>
+          </a:fontRef>
+        </p:style>
+        <p:txBody>
+          <a:bodyPr rtlCol="0" anchor="ctr"/>
+          <a:lstStyle/>
+          <a:p>
+            <a:pPr algn="ctr"/>
+          </a:p>
+        </p:txBody>
+      </p:sp>
+      <p:sp>
+        <p:nvSpPr>
+          <p:cNvPr id="10" name="Rectangle 9"/>
+          <p:cNvSpPr/>
+          <p:nvPr/>
+        </p:nvSpPr>
+        <p:spPr>
+          <a:xfrm>
+            <a:off x="6199632" y="5577840"/>
+            <a:ext cx="82296" cy="777240"/>
+          </a:xfrm>
+          <a:prstGeom prst="rect">
+            <a:avLst/>
+          </a:prstGeom>
+          <a:solidFill>
+            <a:srgbClr val="1F7A4D"/>
+          </a:solidFill>
+          <a:ln>
+            <a:noFill/>
+          </a:ln>
+          <a:effectLst/>
+        </p:spPr>
+        <p:style>
+          <a:lnRef idx="1">
+            <a:schemeClr val="accent1"/>
+          </a:lnRef>
+          <a:fillRef idx="3">
+            <a:schemeClr val="accent1"/>
+          </a:fillRef>
+          <a:effectRef idx="2">
+            <a:schemeClr val="accent1"/>
+          </a:effectRef>
+          <a:fontRef idx="minor">
+            <a:schemeClr val="lt1"/>
+          </a:fontRef>
+        </p:style>
+        <p:txBody>
+          <a:bodyPr rtlCol="0" anchor="ctr"/>
+          <a:lstStyle/>
+          <a:p>
+            <a:pPr algn="ctr"/>
+          </a:p>
+        </p:txBody>
+      </p:sp>
+      <p:sp>
+        <p:nvSpPr>
+          <p:cNvPr id="11" name="TextBox 10"/>
+          <p:cNvSpPr txBox="1"/>
+          <p:nvPr/>
+        </p:nvSpPr>
+        <p:spPr>
+          <a:xfrm>
+            <a:off x="6428232" y="5632704"/>
+            <a:ext cx="5120640" cy="658368"/>
+          </a:xfrm>
+          <a:prstGeom prst="rect">
+            <a:avLst/>
+          </a:prstGeom>
+          <a:noFill/>
+        </p:spPr>
+        <p:txBody>
+          <a:bodyPr wrap="square" anchor="t">
+            <a:spAutoFit/>
+          </a:bodyPr>
+          <a:lstStyle/>
+          <a:p>
+            <a:pPr algn="l">
+              <a:spcAft>
+                <a:spcPts val="400"/>
+              </a:spcAft>
+            </a:pPr>
+            <a:r>
+              <a:rPr sz="1050" b="1" i="0">
+                <a:solidFill>
+                  <a:srgbClr val="1F7A4D"/>
+                </a:solidFill>
+                <a:latin typeface="Segoe UI"/>
+              </a:rPr>
+              <a:t>🎯 PROJEDEKİ ROLÜ</a:t>
+            </a:r>
+          </a:p>
+          <a:p>
+            <a:pPr algn="l">
+              <a:spcAft>
+                <a:spcPts val="400"/>
+              </a:spcAft>
+            </a:pPr>
+            <a:r>
+              <a:rPr sz="1300" b="1" i="0">
+                <a:solidFill>
+                  <a:srgbClr val="1F3B57"/>
+                </a:solidFill>
+                <a:latin typeface="Segoe UI"/>
+              </a:rPr>
+              <a:t>Küçült + kaymalara dayanıklılık</a:t>
+            </a:r>
+          </a:p>
+        </p:txBody>
+      </p:sp>
+      <p:sp>
+        <p:nvSpPr>
+          <p:cNvPr id="12" name="Rectangle 11"/>
           <p:cNvSpPr/>
           <p:nvPr/>
         </p:nvSpPr>
@@ -3860,7 +4150,7 @@
       </p:sp>
       <p:sp>
         <p:nvSpPr>
-          <p:cNvPr id="7" name="TextBox 6"/>
+          <p:cNvPr id="13" name="TextBox 12"/>
           <p:cNvSpPr txBox="1"/>
           <p:nvPr/>
         </p:nvSpPr>
@@ -3899,7 +4189,7 @@
       </p:sp>
       <p:sp>
         <p:nvSpPr>
-          <p:cNvPr id="8" name="TextBox 7"/>
+          <p:cNvPr id="14" name="TextBox 13"/>
           <p:cNvSpPr txBox="1"/>
           <p:nvPr/>
         </p:nvSpPr>
@@ -5198,7 +5488,297 @@
       </p:pic>
       <p:sp>
         <p:nvSpPr>
-          <p:cNvPr id="6" name="Rectangle 5"/>
+          <p:cNvPr id="6" name="Rounded Rectangle 5"/>
+          <p:cNvSpPr/>
+          <p:nvPr/>
+        </p:nvSpPr>
+        <p:spPr>
+          <a:xfrm>
+            <a:off x="548640" y="5577840"/>
+            <a:ext cx="5440680" cy="777240"/>
+          </a:xfrm>
+          <a:prstGeom prst="roundRect">
+            <a:avLst>
+              <a:gd name="adj" fmla="val 8000"/>
+            </a:avLst>
+          </a:prstGeom>
+          <a:solidFill>
+            <a:srgbClr val="E8F1FA"/>
+          </a:solidFill>
+          <a:ln>
+            <a:noFill/>
+          </a:ln>
+          <a:effectLst/>
+        </p:spPr>
+        <p:style>
+          <a:lnRef idx="1">
+            <a:schemeClr val="accent1"/>
+          </a:lnRef>
+          <a:fillRef idx="3">
+            <a:schemeClr val="accent1"/>
+          </a:fillRef>
+          <a:effectRef idx="2">
+            <a:schemeClr val="accent1"/>
+          </a:effectRef>
+          <a:fontRef idx="minor">
+            <a:schemeClr val="lt1"/>
+          </a:fontRef>
+        </p:style>
+        <p:txBody>
+          <a:bodyPr rtlCol="0" anchor="ctr"/>
+          <a:lstStyle/>
+          <a:p>
+            <a:pPr algn="ctr"/>
+          </a:p>
+        </p:txBody>
+      </p:sp>
+      <p:sp>
+        <p:nvSpPr>
+          <p:cNvPr id="7" name="Rectangle 6"/>
+          <p:cNvSpPr/>
+          <p:nvPr/>
+        </p:nvSpPr>
+        <p:spPr>
+          <a:xfrm>
+            <a:off x="548640" y="5577840"/>
+            <a:ext cx="82296" cy="777240"/>
+          </a:xfrm>
+          <a:prstGeom prst="rect">
+            <a:avLst/>
+          </a:prstGeom>
+          <a:solidFill>
+            <a:srgbClr val="2F74C0"/>
+          </a:solidFill>
+          <a:ln>
+            <a:noFill/>
+          </a:ln>
+          <a:effectLst/>
+        </p:spPr>
+        <p:style>
+          <a:lnRef idx="1">
+            <a:schemeClr val="accent1"/>
+          </a:lnRef>
+          <a:fillRef idx="3">
+            <a:schemeClr val="accent1"/>
+          </a:fillRef>
+          <a:effectRef idx="2">
+            <a:schemeClr val="accent1"/>
+          </a:effectRef>
+          <a:fontRef idx="minor">
+            <a:schemeClr val="lt1"/>
+          </a:fontRef>
+        </p:style>
+        <p:txBody>
+          <a:bodyPr rtlCol="0" anchor="ctr"/>
+          <a:lstStyle/>
+          <a:p>
+            <a:pPr algn="ctr"/>
+          </a:p>
+        </p:txBody>
+      </p:sp>
+      <p:sp>
+        <p:nvSpPr>
+          <p:cNvPr id="8" name="TextBox 7"/>
+          <p:cNvSpPr txBox="1"/>
+          <p:nvPr/>
+        </p:nvSpPr>
+        <p:spPr>
+          <a:xfrm>
+            <a:off x="777240" y="5632704"/>
+            <a:ext cx="5120640" cy="658368"/>
+          </a:xfrm>
+          <a:prstGeom prst="rect">
+            <a:avLst/>
+          </a:prstGeom>
+          <a:noFill/>
+        </p:spPr>
+        <p:txBody>
+          <a:bodyPr wrap="square" anchor="t">
+            <a:spAutoFit/>
+          </a:bodyPr>
+          <a:lstStyle/>
+          <a:p>
+            <a:pPr algn="l">
+              <a:spcAft>
+                <a:spcPts val="400"/>
+              </a:spcAft>
+            </a:pPr>
+            <a:r>
+              <a:rPr sz="1050" b="1" i="0">
+                <a:solidFill>
+                  <a:srgbClr val="2F74C0"/>
+                </a:solidFill>
+                <a:latin typeface="Segoe UI"/>
+              </a:rPr>
+              <a:t>⚙ NASIL ÇALIŞIR</a:t>
+            </a:r>
+          </a:p>
+          <a:p>
+            <a:pPr algn="l">
+              <a:spcAft>
+                <a:spcPts val="400"/>
+              </a:spcAft>
+            </a:pPr>
+            <a:r>
+              <a:rPr sz="1300" b="1" i="0">
+                <a:solidFill>
+                  <a:srgbClr val="1F3B57"/>
+                </a:solidFill>
+                <a:latin typeface="Segoe UI"/>
+              </a:rPr>
+              <a:t>32 pencere × 200 ms, eşit yerleşim</a:t>
+            </a:r>
+          </a:p>
+        </p:txBody>
+      </p:sp>
+      <p:sp>
+        <p:nvSpPr>
+          <p:cNvPr id="9" name="Rounded Rectangle 8"/>
+          <p:cNvSpPr/>
+          <p:nvPr/>
+        </p:nvSpPr>
+        <p:spPr>
+          <a:xfrm>
+            <a:off x="6199632" y="5577840"/>
+            <a:ext cx="5440680" cy="777240"/>
+          </a:xfrm>
+          <a:prstGeom prst="roundRect">
+            <a:avLst>
+              <a:gd name="adj" fmla="val 8000"/>
+            </a:avLst>
+          </a:prstGeom>
+          <a:solidFill>
+            <a:srgbClr val="E9F6EF"/>
+          </a:solidFill>
+          <a:ln>
+            <a:noFill/>
+          </a:ln>
+          <a:effectLst/>
+        </p:spPr>
+        <p:style>
+          <a:lnRef idx="1">
+            <a:schemeClr val="accent1"/>
+          </a:lnRef>
+          <a:fillRef idx="3">
+            <a:schemeClr val="accent1"/>
+          </a:fillRef>
+          <a:effectRef idx="2">
+            <a:schemeClr val="accent1"/>
+          </a:effectRef>
+          <a:fontRef idx="minor">
+            <a:schemeClr val="lt1"/>
+          </a:fontRef>
+        </p:style>
+        <p:txBody>
+          <a:bodyPr rtlCol="0" anchor="ctr"/>
+          <a:lstStyle/>
+          <a:p>
+            <a:pPr algn="ctr"/>
+          </a:p>
+        </p:txBody>
+      </p:sp>
+      <p:sp>
+        <p:nvSpPr>
+          <p:cNvPr id="10" name="Rectangle 9"/>
+          <p:cNvSpPr/>
+          <p:nvPr/>
+        </p:nvSpPr>
+        <p:spPr>
+          <a:xfrm>
+            <a:off x="6199632" y="5577840"/>
+            <a:ext cx="82296" cy="777240"/>
+          </a:xfrm>
+          <a:prstGeom prst="rect">
+            <a:avLst/>
+          </a:prstGeom>
+          <a:solidFill>
+            <a:srgbClr val="1F7A4D"/>
+          </a:solidFill>
+          <a:ln>
+            <a:noFill/>
+          </a:ln>
+          <a:effectLst/>
+        </p:spPr>
+        <p:style>
+          <a:lnRef idx="1">
+            <a:schemeClr val="accent1"/>
+          </a:lnRef>
+          <a:fillRef idx="3">
+            <a:schemeClr val="accent1"/>
+          </a:fillRef>
+          <a:effectRef idx="2">
+            <a:schemeClr val="accent1"/>
+          </a:effectRef>
+          <a:fontRef idx="minor">
+            <a:schemeClr val="lt1"/>
+          </a:fontRef>
+        </p:style>
+        <p:txBody>
+          <a:bodyPr rtlCol="0" anchor="ctr"/>
+          <a:lstStyle/>
+          <a:p>
+            <a:pPr algn="ctr"/>
+          </a:p>
+        </p:txBody>
+      </p:sp>
+      <p:sp>
+        <p:nvSpPr>
+          <p:cNvPr id="11" name="TextBox 10"/>
+          <p:cNvSpPr txBox="1"/>
+          <p:nvPr/>
+        </p:nvSpPr>
+        <p:spPr>
+          <a:xfrm>
+            <a:off x="6428232" y="5632704"/>
+            <a:ext cx="5120640" cy="658368"/>
+          </a:xfrm>
+          <a:prstGeom prst="rect">
+            <a:avLst/>
+          </a:prstGeom>
+          <a:noFill/>
+        </p:spPr>
+        <p:txBody>
+          <a:bodyPr wrap="square" anchor="t">
+            <a:spAutoFit/>
+          </a:bodyPr>
+          <a:lstStyle/>
+          <a:p>
+            <a:pPr algn="l">
+              <a:spcAft>
+                <a:spcPts val="400"/>
+              </a:spcAft>
+            </a:pPr>
+            <a:r>
+              <a:rPr sz="1050" b="1" i="0">
+                <a:solidFill>
+                  <a:srgbClr val="1F7A4D"/>
+                </a:solidFill>
+                <a:latin typeface="Segoe UI"/>
+              </a:rPr>
+              <a:t>🎯 PROJEDEKİ ROLÜ</a:t>
+            </a:r>
+          </a:p>
+          <a:p>
+            <a:pPr algn="l">
+              <a:spcAft>
+                <a:spcPts val="400"/>
+              </a:spcAft>
+            </a:pPr>
+            <a:r>
+              <a:rPr sz="1300" b="1" i="0">
+                <a:solidFill>
+                  <a:srgbClr val="1F3B57"/>
+                </a:solidFill>
+                <a:latin typeface="Segoe UI"/>
+              </a:rPr>
+              <a:t>Kazanan hiperparametre → %63,8</a:t>
+            </a:r>
+          </a:p>
+        </p:txBody>
+      </p:sp>
+      <p:sp>
+        <p:nvSpPr>
+          <p:cNvPr id="12" name="Rectangle 11"/>
           <p:cNvSpPr/>
           <p:nvPr/>
         </p:nvSpPr>
@@ -5242,7 +5822,7 @@
       </p:sp>
       <p:sp>
         <p:nvSpPr>
-          <p:cNvPr id="7" name="TextBox 6"/>
+          <p:cNvPr id="13" name="TextBox 12"/>
           <p:cNvSpPr txBox="1"/>
           <p:nvPr/>
         </p:nvSpPr>
@@ -5281,7 +5861,7 @@
       </p:sp>
       <p:sp>
         <p:nvSpPr>
-          <p:cNvPr id="8" name="TextBox 7"/>
+          <p:cNvPr id="14" name="TextBox 13"/>
           <p:cNvSpPr txBox="1"/>
           <p:nvPr/>
         </p:nvSpPr>
@@ -5495,8 +6075,8 @@
         </p:blipFill>
         <p:spPr>
           <a:xfrm>
-            <a:off x="1295247" y="1463040"/>
-            <a:ext cx="9601200" cy="4267200"/>
+            <a:off x="1706727" y="1280160"/>
+            <a:ext cx="8778240" cy="3901440"/>
           </a:xfrm>
           <a:prstGeom prst="rect">
             <a:avLst/>
@@ -5505,7 +6085,297 @@
       </p:pic>
       <p:sp>
         <p:nvSpPr>
-          <p:cNvPr id="6" name="Rectangle 5"/>
+          <p:cNvPr id="6" name="Rounded Rectangle 5"/>
+          <p:cNvSpPr/>
+          <p:nvPr/>
+        </p:nvSpPr>
+        <p:spPr>
+          <a:xfrm>
+            <a:off x="548640" y="5577840"/>
+            <a:ext cx="5440680" cy="777240"/>
+          </a:xfrm>
+          <a:prstGeom prst="roundRect">
+            <a:avLst>
+              <a:gd name="adj" fmla="val 8000"/>
+            </a:avLst>
+          </a:prstGeom>
+          <a:solidFill>
+            <a:srgbClr val="E8F1FA"/>
+          </a:solidFill>
+          <a:ln>
+            <a:noFill/>
+          </a:ln>
+          <a:effectLst/>
+        </p:spPr>
+        <p:style>
+          <a:lnRef idx="1">
+            <a:schemeClr val="accent1"/>
+          </a:lnRef>
+          <a:fillRef idx="3">
+            <a:schemeClr val="accent1"/>
+          </a:fillRef>
+          <a:effectRef idx="2">
+            <a:schemeClr val="accent1"/>
+          </a:effectRef>
+          <a:fontRef idx="minor">
+            <a:schemeClr val="lt1"/>
+          </a:fontRef>
+        </p:style>
+        <p:txBody>
+          <a:bodyPr rtlCol="0" anchor="ctr"/>
+          <a:lstStyle/>
+          <a:p>
+            <a:pPr algn="ctr"/>
+          </a:p>
+        </p:txBody>
+      </p:sp>
+      <p:sp>
+        <p:nvSpPr>
+          <p:cNvPr id="7" name="Rectangle 6"/>
+          <p:cNvSpPr/>
+          <p:nvPr/>
+        </p:nvSpPr>
+        <p:spPr>
+          <a:xfrm>
+            <a:off x="548640" y="5577840"/>
+            <a:ext cx="82296" cy="777240"/>
+          </a:xfrm>
+          <a:prstGeom prst="rect">
+            <a:avLst/>
+          </a:prstGeom>
+          <a:solidFill>
+            <a:srgbClr val="2F74C0"/>
+          </a:solidFill>
+          <a:ln>
+            <a:noFill/>
+          </a:ln>
+          <a:effectLst/>
+        </p:spPr>
+        <p:style>
+          <a:lnRef idx="1">
+            <a:schemeClr val="accent1"/>
+          </a:lnRef>
+          <a:fillRef idx="3">
+            <a:schemeClr val="accent1"/>
+          </a:fillRef>
+          <a:effectRef idx="2">
+            <a:schemeClr val="accent1"/>
+          </a:effectRef>
+          <a:fontRef idx="minor">
+            <a:schemeClr val="lt1"/>
+          </a:fontRef>
+        </p:style>
+        <p:txBody>
+          <a:bodyPr rtlCol="0" anchor="ctr"/>
+          <a:lstStyle/>
+          <a:p>
+            <a:pPr algn="ctr"/>
+          </a:p>
+        </p:txBody>
+      </p:sp>
+      <p:sp>
+        <p:nvSpPr>
+          <p:cNvPr id="8" name="TextBox 7"/>
+          <p:cNvSpPr txBox="1"/>
+          <p:nvPr/>
+        </p:nvSpPr>
+        <p:spPr>
+          <a:xfrm>
+            <a:off x="777240" y="5632704"/>
+            <a:ext cx="5120640" cy="658368"/>
+          </a:xfrm>
+          <a:prstGeom prst="rect">
+            <a:avLst/>
+          </a:prstGeom>
+          <a:noFill/>
+        </p:spPr>
+        <p:txBody>
+          <a:bodyPr wrap="square" anchor="t">
+            <a:spAutoFit/>
+          </a:bodyPr>
+          <a:lstStyle/>
+          <a:p>
+            <a:pPr algn="l">
+              <a:spcAft>
+                <a:spcPts val="400"/>
+              </a:spcAft>
+            </a:pPr>
+            <a:r>
+              <a:rPr sz="1050" b="1" i="0">
+                <a:solidFill>
+                  <a:srgbClr val="2F74C0"/>
+                </a:solidFill>
+                <a:latin typeface="Segoe UI"/>
+              </a:rPr>
+              <a:t>⚙ NASIL ÇALIŞIR</a:t>
+            </a:r>
+          </a:p>
+          <a:p>
+            <a:pPr algn="l">
+              <a:spcAft>
+                <a:spcPts val="400"/>
+              </a:spcAft>
+            </a:pPr>
+            <a:r>
+              <a:rPr sz="1300" b="1" i="0">
+                <a:solidFill>
+                  <a:srgbClr val="1F3B57"/>
+                </a:solidFill>
+                <a:latin typeface="Segoe UI"/>
+              </a:rPr>
+              <a:t>z kapısı: defterin ne kadarı güncellensin</a:t>
+            </a:r>
+          </a:p>
+        </p:txBody>
+      </p:sp>
+      <p:sp>
+        <p:nvSpPr>
+          <p:cNvPr id="9" name="Rounded Rectangle 8"/>
+          <p:cNvSpPr/>
+          <p:nvPr/>
+        </p:nvSpPr>
+        <p:spPr>
+          <a:xfrm>
+            <a:off x="6199632" y="5577840"/>
+            <a:ext cx="5440680" cy="777240"/>
+          </a:xfrm>
+          <a:prstGeom prst="roundRect">
+            <a:avLst>
+              <a:gd name="adj" fmla="val 8000"/>
+            </a:avLst>
+          </a:prstGeom>
+          <a:solidFill>
+            <a:srgbClr val="E9F6EF"/>
+          </a:solidFill>
+          <a:ln>
+            <a:noFill/>
+          </a:ln>
+          <a:effectLst/>
+        </p:spPr>
+        <p:style>
+          <a:lnRef idx="1">
+            <a:schemeClr val="accent1"/>
+          </a:lnRef>
+          <a:fillRef idx="3">
+            <a:schemeClr val="accent1"/>
+          </a:fillRef>
+          <a:effectRef idx="2">
+            <a:schemeClr val="accent1"/>
+          </a:effectRef>
+          <a:fontRef idx="minor">
+            <a:schemeClr val="lt1"/>
+          </a:fontRef>
+        </p:style>
+        <p:txBody>
+          <a:bodyPr rtlCol="0" anchor="ctr"/>
+          <a:lstStyle/>
+          <a:p>
+            <a:pPr algn="ctr"/>
+          </a:p>
+        </p:txBody>
+      </p:sp>
+      <p:sp>
+        <p:nvSpPr>
+          <p:cNvPr id="10" name="Rectangle 9"/>
+          <p:cNvSpPr/>
+          <p:nvPr/>
+        </p:nvSpPr>
+        <p:spPr>
+          <a:xfrm>
+            <a:off x="6199632" y="5577840"/>
+            <a:ext cx="82296" cy="777240"/>
+          </a:xfrm>
+          <a:prstGeom prst="rect">
+            <a:avLst/>
+          </a:prstGeom>
+          <a:solidFill>
+            <a:srgbClr val="1F7A4D"/>
+          </a:solidFill>
+          <a:ln>
+            <a:noFill/>
+          </a:ln>
+          <a:effectLst/>
+        </p:spPr>
+        <p:style>
+          <a:lnRef idx="1">
+            <a:schemeClr val="accent1"/>
+          </a:lnRef>
+          <a:fillRef idx="3">
+            <a:schemeClr val="accent1"/>
+          </a:fillRef>
+          <a:effectRef idx="2">
+            <a:schemeClr val="accent1"/>
+          </a:effectRef>
+          <a:fontRef idx="minor">
+            <a:schemeClr val="lt1"/>
+          </a:fontRef>
+        </p:style>
+        <p:txBody>
+          <a:bodyPr rtlCol="0" anchor="ctr"/>
+          <a:lstStyle/>
+          <a:p>
+            <a:pPr algn="ctr"/>
+          </a:p>
+        </p:txBody>
+      </p:sp>
+      <p:sp>
+        <p:nvSpPr>
+          <p:cNvPr id="11" name="TextBox 10"/>
+          <p:cNvSpPr txBox="1"/>
+          <p:nvPr/>
+        </p:nvSpPr>
+        <p:spPr>
+          <a:xfrm>
+            <a:off x="6428232" y="5632704"/>
+            <a:ext cx="5120640" cy="658368"/>
+          </a:xfrm>
+          <a:prstGeom prst="rect">
+            <a:avLst/>
+          </a:prstGeom>
+          <a:noFill/>
+        </p:spPr>
+        <p:txBody>
+          <a:bodyPr wrap="square" anchor="t">
+            <a:spAutoFit/>
+          </a:bodyPr>
+          <a:lstStyle/>
+          <a:p>
+            <a:pPr algn="l">
+              <a:spcAft>
+                <a:spcPts val="400"/>
+              </a:spcAft>
+            </a:pPr>
+            <a:r>
+              <a:rPr sz="1050" b="1" i="0">
+                <a:solidFill>
+                  <a:srgbClr val="1F7A4D"/>
+                </a:solidFill>
+                <a:latin typeface="Segoe UI"/>
+              </a:rPr>
+              <a:t>🎯 PROJEDEKİ ROLÜ</a:t>
+            </a:r>
+          </a:p>
+          <a:p>
+            <a:pPr algn="l">
+              <a:spcAft>
+                <a:spcPts val="400"/>
+              </a:spcAft>
+            </a:pPr>
+            <a:r>
+              <a:rPr sz="1300" b="1" i="0">
+                <a:solidFill>
+                  <a:srgbClr val="1F3B57"/>
+                </a:solidFill>
+                <a:latin typeface="Segoe UI"/>
+              </a:rPr>
+              <a:t>Duygunun zaman seyrini okur</a:t>
+            </a:r>
+          </a:p>
+        </p:txBody>
+      </p:sp>
+      <p:sp>
+        <p:nvSpPr>
+          <p:cNvPr id="12" name="Rectangle 11"/>
           <p:cNvSpPr/>
           <p:nvPr/>
         </p:nvSpPr>
@@ -5549,7 +6419,7 @@
       </p:sp>
       <p:sp>
         <p:nvSpPr>
-          <p:cNvPr id="7" name="TextBox 6"/>
+          <p:cNvPr id="13" name="TextBox 12"/>
           <p:cNvSpPr txBox="1"/>
           <p:nvPr/>
         </p:nvSpPr>
@@ -5588,7 +6458,7 @@
       </p:sp>
       <p:sp>
         <p:nvSpPr>
-          <p:cNvPr id="8" name="TextBox 7"/>
+          <p:cNvPr id="14" name="TextBox 13"/>
           <p:cNvSpPr txBox="1"/>
           <p:nvPr/>
         </p:nvSpPr>
@@ -6468,8 +7338,8 @@
         </p:blipFill>
         <p:spPr>
           <a:xfrm>
-            <a:off x="1295247" y="1645920"/>
-            <a:ext cx="9601200" cy="3840480"/>
+            <a:off x="1523847" y="1417320"/>
+            <a:ext cx="9144000" cy="3657600"/>
           </a:xfrm>
           <a:prstGeom prst="rect">
             <a:avLst/>
@@ -6478,7 +7348,297 @@
       </p:pic>
       <p:sp>
         <p:nvSpPr>
-          <p:cNvPr id="6" name="Rectangle 5"/>
+          <p:cNvPr id="6" name="Rounded Rectangle 5"/>
+          <p:cNvSpPr/>
+          <p:nvPr/>
+        </p:nvSpPr>
+        <p:spPr>
+          <a:xfrm>
+            <a:off x="548640" y="5577840"/>
+            <a:ext cx="5440680" cy="777240"/>
+          </a:xfrm>
+          <a:prstGeom prst="roundRect">
+            <a:avLst>
+              <a:gd name="adj" fmla="val 8000"/>
+            </a:avLst>
+          </a:prstGeom>
+          <a:solidFill>
+            <a:srgbClr val="E8F1FA"/>
+          </a:solidFill>
+          <a:ln>
+            <a:noFill/>
+          </a:ln>
+          <a:effectLst/>
+        </p:spPr>
+        <p:style>
+          <a:lnRef idx="1">
+            <a:schemeClr val="accent1"/>
+          </a:lnRef>
+          <a:fillRef idx="3">
+            <a:schemeClr val="accent1"/>
+          </a:fillRef>
+          <a:effectRef idx="2">
+            <a:schemeClr val="accent1"/>
+          </a:effectRef>
+          <a:fontRef idx="minor">
+            <a:schemeClr val="lt1"/>
+          </a:fontRef>
+        </p:style>
+        <p:txBody>
+          <a:bodyPr rtlCol="0" anchor="ctr"/>
+          <a:lstStyle/>
+          <a:p>
+            <a:pPr algn="ctr"/>
+          </a:p>
+        </p:txBody>
+      </p:sp>
+      <p:sp>
+        <p:nvSpPr>
+          <p:cNvPr id="7" name="Rectangle 6"/>
+          <p:cNvSpPr/>
+          <p:nvPr/>
+        </p:nvSpPr>
+        <p:spPr>
+          <a:xfrm>
+            <a:off x="548640" y="5577840"/>
+            <a:ext cx="82296" cy="777240"/>
+          </a:xfrm>
+          <a:prstGeom prst="rect">
+            <a:avLst/>
+          </a:prstGeom>
+          <a:solidFill>
+            <a:srgbClr val="2F74C0"/>
+          </a:solidFill>
+          <a:ln>
+            <a:noFill/>
+          </a:ln>
+          <a:effectLst/>
+        </p:spPr>
+        <p:style>
+          <a:lnRef idx="1">
+            <a:schemeClr val="accent1"/>
+          </a:lnRef>
+          <a:fillRef idx="3">
+            <a:schemeClr val="accent1"/>
+          </a:fillRef>
+          <a:effectRef idx="2">
+            <a:schemeClr val="accent1"/>
+          </a:effectRef>
+          <a:fontRef idx="minor">
+            <a:schemeClr val="lt1"/>
+          </a:fontRef>
+        </p:style>
+        <p:txBody>
+          <a:bodyPr rtlCol="0" anchor="ctr"/>
+          <a:lstStyle/>
+          <a:p>
+            <a:pPr algn="ctr"/>
+          </a:p>
+        </p:txBody>
+      </p:sp>
+      <p:sp>
+        <p:nvSpPr>
+          <p:cNvPr id="8" name="TextBox 7"/>
+          <p:cNvSpPr txBox="1"/>
+          <p:nvPr/>
+        </p:nvSpPr>
+        <p:spPr>
+          <a:xfrm>
+            <a:off x="777240" y="5632704"/>
+            <a:ext cx="5120640" cy="658368"/>
+          </a:xfrm>
+          <a:prstGeom prst="rect">
+            <a:avLst/>
+          </a:prstGeom>
+          <a:noFill/>
+        </p:spPr>
+        <p:txBody>
+          <a:bodyPr wrap="square" anchor="t">
+            <a:spAutoFit/>
+          </a:bodyPr>
+          <a:lstStyle/>
+          <a:p>
+            <a:pPr algn="l">
+              <a:spcAft>
+                <a:spcPts val="400"/>
+              </a:spcAft>
+            </a:pPr>
+            <a:r>
+              <a:rPr sz="1050" b="1" i="0">
+                <a:solidFill>
+                  <a:srgbClr val="2F74C0"/>
+                </a:solidFill>
+                <a:latin typeface="Segoe UI"/>
+              </a:rPr>
+              <a:t>⚙ NASIL ÇALIŞIR</a:t>
+            </a:r>
+          </a:p>
+          <a:p>
+            <a:pPr algn="l">
+              <a:spcAft>
+                <a:spcPts val="400"/>
+              </a:spcAft>
+            </a:pPr>
+            <a:r>
+              <a:rPr sz="1300" b="1" i="0">
+                <a:solidFill>
+                  <a:srgbClr val="1F3B57"/>
+                </a:solidFill>
+                <a:latin typeface="Segoe UI"/>
+              </a:rPr>
+              <a:t>w = n/(6·n_k): az sınıfa büyük ağırlık</a:t>
+            </a:r>
+          </a:p>
+        </p:txBody>
+      </p:sp>
+      <p:sp>
+        <p:nvSpPr>
+          <p:cNvPr id="9" name="Rounded Rectangle 8"/>
+          <p:cNvSpPr/>
+          <p:nvPr/>
+        </p:nvSpPr>
+        <p:spPr>
+          <a:xfrm>
+            <a:off x="6199632" y="5577840"/>
+            <a:ext cx="5440680" cy="777240"/>
+          </a:xfrm>
+          <a:prstGeom prst="roundRect">
+            <a:avLst>
+              <a:gd name="adj" fmla="val 8000"/>
+            </a:avLst>
+          </a:prstGeom>
+          <a:solidFill>
+            <a:srgbClr val="E9F6EF"/>
+          </a:solidFill>
+          <a:ln>
+            <a:noFill/>
+          </a:ln>
+          <a:effectLst/>
+        </p:spPr>
+        <p:style>
+          <a:lnRef idx="1">
+            <a:schemeClr val="accent1"/>
+          </a:lnRef>
+          <a:fillRef idx="3">
+            <a:schemeClr val="accent1"/>
+          </a:fillRef>
+          <a:effectRef idx="2">
+            <a:schemeClr val="accent1"/>
+          </a:effectRef>
+          <a:fontRef idx="minor">
+            <a:schemeClr val="lt1"/>
+          </a:fontRef>
+        </p:style>
+        <p:txBody>
+          <a:bodyPr rtlCol="0" anchor="ctr"/>
+          <a:lstStyle/>
+          <a:p>
+            <a:pPr algn="ctr"/>
+          </a:p>
+        </p:txBody>
+      </p:sp>
+      <p:sp>
+        <p:nvSpPr>
+          <p:cNvPr id="10" name="Rectangle 9"/>
+          <p:cNvSpPr/>
+          <p:nvPr/>
+        </p:nvSpPr>
+        <p:spPr>
+          <a:xfrm>
+            <a:off x="6199632" y="5577840"/>
+            <a:ext cx="82296" cy="777240"/>
+          </a:xfrm>
+          <a:prstGeom prst="rect">
+            <a:avLst/>
+          </a:prstGeom>
+          <a:solidFill>
+            <a:srgbClr val="1F7A4D"/>
+          </a:solidFill>
+          <a:ln>
+            <a:noFill/>
+          </a:ln>
+          <a:effectLst/>
+        </p:spPr>
+        <p:style>
+          <a:lnRef idx="1">
+            <a:schemeClr val="accent1"/>
+          </a:lnRef>
+          <a:fillRef idx="3">
+            <a:schemeClr val="accent1"/>
+          </a:fillRef>
+          <a:effectRef idx="2">
+            <a:schemeClr val="accent1"/>
+          </a:effectRef>
+          <a:fontRef idx="minor">
+            <a:schemeClr val="lt1"/>
+          </a:fontRef>
+        </p:style>
+        <p:txBody>
+          <a:bodyPr rtlCol="0" anchor="ctr"/>
+          <a:lstStyle/>
+          <a:p>
+            <a:pPr algn="ctr"/>
+          </a:p>
+        </p:txBody>
+      </p:sp>
+      <p:sp>
+        <p:nvSpPr>
+          <p:cNvPr id="11" name="TextBox 10"/>
+          <p:cNvSpPr txBox="1"/>
+          <p:nvPr/>
+        </p:nvSpPr>
+        <p:spPr>
+          <a:xfrm>
+            <a:off x="6428232" y="5632704"/>
+            <a:ext cx="5120640" cy="658368"/>
+          </a:xfrm>
+          <a:prstGeom prst="rect">
+            <a:avLst/>
+          </a:prstGeom>
+          <a:noFill/>
+        </p:spPr>
+        <p:txBody>
+          <a:bodyPr wrap="square" anchor="t">
+            <a:spAutoFit/>
+          </a:bodyPr>
+          <a:lstStyle/>
+          <a:p>
+            <a:pPr algn="l">
+              <a:spcAft>
+                <a:spcPts val="400"/>
+              </a:spcAft>
+            </a:pPr>
+            <a:r>
+              <a:rPr sz="1050" b="1" i="0">
+                <a:solidFill>
+                  <a:srgbClr val="1F7A4D"/>
+                </a:solidFill>
+                <a:latin typeface="Segoe UI"/>
+              </a:rPr>
+              <a:t>🎯 PROJEDEKİ ROLÜ</a:t>
+            </a:r>
+          </a:p>
+          <a:p>
+            <a:pPr algn="l">
+              <a:spcAft>
+                <a:spcPts val="400"/>
+              </a:spcAft>
+            </a:pPr>
+            <a:r>
+              <a:rPr sz="1300" b="1" i="0">
+                <a:solidFill>
+                  <a:srgbClr val="1F3B57"/>
+                </a:solidFill>
+                <a:latin typeface="Segoe UI"/>
+              </a:rPr>
+              <a:t>Nötr ihmalini engelledi (w=1,14)</a:t>
+            </a:r>
+          </a:p>
+        </p:txBody>
+      </p:sp>
+      <p:sp>
+        <p:nvSpPr>
+          <p:cNvPr id="12" name="Rectangle 11"/>
           <p:cNvSpPr/>
           <p:nvPr/>
         </p:nvSpPr>
@@ -6522,7 +7682,7 @@
       </p:sp>
       <p:sp>
         <p:nvSpPr>
-          <p:cNvPr id="7" name="TextBox 6"/>
+          <p:cNvPr id="13" name="TextBox 12"/>
           <p:cNvSpPr txBox="1"/>
           <p:nvPr/>
         </p:nvSpPr>
@@ -6561,7 +7721,7 @@
       </p:sp>
       <p:sp>
         <p:nvSpPr>
-          <p:cNvPr id="8" name="TextBox 7"/>
+          <p:cNvPr id="14" name="TextBox 13"/>
           <p:cNvSpPr txBox="1"/>
           <p:nvPr/>
         </p:nvSpPr>
@@ -6775,8 +7935,8 @@
         </p:blipFill>
         <p:spPr>
           <a:xfrm>
-            <a:off x="1295247" y="1645920"/>
-            <a:ext cx="9601200" cy="3627120"/>
+            <a:off x="1432407" y="1371600"/>
+            <a:ext cx="9326880" cy="3523488"/>
           </a:xfrm>
           <a:prstGeom prst="rect">
             <a:avLst/>
@@ -6785,7 +7945,297 @@
       </p:pic>
       <p:sp>
         <p:nvSpPr>
-          <p:cNvPr id="6" name="Rectangle 5"/>
+          <p:cNvPr id="6" name="Rounded Rectangle 5"/>
+          <p:cNvSpPr/>
+          <p:nvPr/>
+        </p:nvSpPr>
+        <p:spPr>
+          <a:xfrm>
+            <a:off x="548640" y="5577840"/>
+            <a:ext cx="5440680" cy="777240"/>
+          </a:xfrm>
+          <a:prstGeom prst="roundRect">
+            <a:avLst>
+              <a:gd name="adj" fmla="val 8000"/>
+            </a:avLst>
+          </a:prstGeom>
+          <a:solidFill>
+            <a:srgbClr val="E8F1FA"/>
+          </a:solidFill>
+          <a:ln>
+            <a:noFill/>
+          </a:ln>
+          <a:effectLst/>
+        </p:spPr>
+        <p:style>
+          <a:lnRef idx="1">
+            <a:schemeClr val="accent1"/>
+          </a:lnRef>
+          <a:fillRef idx="3">
+            <a:schemeClr val="accent1"/>
+          </a:fillRef>
+          <a:effectRef idx="2">
+            <a:schemeClr val="accent1"/>
+          </a:effectRef>
+          <a:fontRef idx="minor">
+            <a:schemeClr val="lt1"/>
+          </a:fontRef>
+        </p:style>
+        <p:txBody>
+          <a:bodyPr rtlCol="0" anchor="ctr"/>
+          <a:lstStyle/>
+          <a:p>
+            <a:pPr algn="ctr"/>
+          </a:p>
+        </p:txBody>
+      </p:sp>
+      <p:sp>
+        <p:nvSpPr>
+          <p:cNvPr id="7" name="Rectangle 6"/>
+          <p:cNvSpPr/>
+          <p:nvPr/>
+        </p:nvSpPr>
+        <p:spPr>
+          <a:xfrm>
+            <a:off x="548640" y="5577840"/>
+            <a:ext cx="82296" cy="777240"/>
+          </a:xfrm>
+          <a:prstGeom prst="rect">
+            <a:avLst/>
+          </a:prstGeom>
+          <a:solidFill>
+            <a:srgbClr val="2F74C0"/>
+          </a:solidFill>
+          <a:ln>
+            <a:noFill/>
+          </a:ln>
+          <a:effectLst/>
+        </p:spPr>
+        <p:style>
+          <a:lnRef idx="1">
+            <a:schemeClr val="accent1"/>
+          </a:lnRef>
+          <a:fillRef idx="3">
+            <a:schemeClr val="accent1"/>
+          </a:fillRef>
+          <a:effectRef idx="2">
+            <a:schemeClr val="accent1"/>
+          </a:effectRef>
+          <a:fontRef idx="minor">
+            <a:schemeClr val="lt1"/>
+          </a:fontRef>
+        </p:style>
+        <p:txBody>
+          <a:bodyPr rtlCol="0" anchor="ctr"/>
+          <a:lstStyle/>
+          <a:p>
+            <a:pPr algn="ctr"/>
+          </a:p>
+        </p:txBody>
+      </p:sp>
+      <p:sp>
+        <p:nvSpPr>
+          <p:cNvPr id="8" name="TextBox 7"/>
+          <p:cNvSpPr txBox="1"/>
+          <p:nvPr/>
+        </p:nvSpPr>
+        <p:spPr>
+          <a:xfrm>
+            <a:off x="777240" y="5632704"/>
+            <a:ext cx="5120640" cy="658368"/>
+          </a:xfrm>
+          <a:prstGeom prst="rect">
+            <a:avLst/>
+          </a:prstGeom>
+          <a:noFill/>
+        </p:spPr>
+        <p:txBody>
+          <a:bodyPr wrap="square" anchor="t">
+            <a:spAutoFit/>
+          </a:bodyPr>
+          <a:lstStyle/>
+          <a:p>
+            <a:pPr algn="l">
+              <a:spcAft>
+                <a:spcPts val="400"/>
+              </a:spcAft>
+            </a:pPr>
+            <a:r>
+              <a:rPr sz="1050" b="1" i="0">
+                <a:solidFill>
+                  <a:srgbClr val="2F74C0"/>
+                </a:solidFill>
+                <a:latin typeface="Segoe UI"/>
+              </a:rPr>
+              <a:t>⚙ NASIL ÇALIŞIR</a:t>
+            </a:r>
+          </a:p>
+          <a:p>
+            <a:pPr algn="l">
+              <a:spcAft>
+                <a:spcPts val="400"/>
+              </a:spcAft>
+            </a:pPr>
+            <a:r>
+              <a:rPr sz="1300" b="1" i="0">
+                <a:solidFill>
+                  <a:srgbClr val="1F3B57"/>
+                </a:solidFill>
+                <a:latin typeface="Segoe UI"/>
+              </a:rPr>
+              <a:t>e^puan / toplam → %100 dağılım</a:t>
+            </a:r>
+          </a:p>
+        </p:txBody>
+      </p:sp>
+      <p:sp>
+        <p:nvSpPr>
+          <p:cNvPr id="9" name="Rounded Rectangle 8"/>
+          <p:cNvSpPr/>
+          <p:nvPr/>
+        </p:nvSpPr>
+        <p:spPr>
+          <a:xfrm>
+            <a:off x="6199632" y="5577840"/>
+            <a:ext cx="5440680" cy="777240"/>
+          </a:xfrm>
+          <a:prstGeom prst="roundRect">
+            <a:avLst>
+              <a:gd name="adj" fmla="val 8000"/>
+            </a:avLst>
+          </a:prstGeom>
+          <a:solidFill>
+            <a:srgbClr val="E9F6EF"/>
+          </a:solidFill>
+          <a:ln>
+            <a:noFill/>
+          </a:ln>
+          <a:effectLst/>
+        </p:spPr>
+        <p:style>
+          <a:lnRef idx="1">
+            <a:schemeClr val="accent1"/>
+          </a:lnRef>
+          <a:fillRef idx="3">
+            <a:schemeClr val="accent1"/>
+          </a:fillRef>
+          <a:effectRef idx="2">
+            <a:schemeClr val="accent1"/>
+          </a:effectRef>
+          <a:fontRef idx="minor">
+            <a:schemeClr val="lt1"/>
+          </a:fontRef>
+        </p:style>
+        <p:txBody>
+          <a:bodyPr rtlCol="0" anchor="ctr"/>
+          <a:lstStyle/>
+          <a:p>
+            <a:pPr algn="ctr"/>
+          </a:p>
+        </p:txBody>
+      </p:sp>
+      <p:sp>
+        <p:nvSpPr>
+          <p:cNvPr id="10" name="Rectangle 9"/>
+          <p:cNvSpPr/>
+          <p:nvPr/>
+        </p:nvSpPr>
+        <p:spPr>
+          <a:xfrm>
+            <a:off x="6199632" y="5577840"/>
+            <a:ext cx="82296" cy="777240"/>
+          </a:xfrm>
+          <a:prstGeom prst="rect">
+            <a:avLst/>
+          </a:prstGeom>
+          <a:solidFill>
+            <a:srgbClr val="1F7A4D"/>
+          </a:solidFill>
+          <a:ln>
+            <a:noFill/>
+          </a:ln>
+          <a:effectLst/>
+        </p:spPr>
+        <p:style>
+          <a:lnRef idx="1">
+            <a:schemeClr val="accent1"/>
+          </a:lnRef>
+          <a:fillRef idx="3">
+            <a:schemeClr val="accent1"/>
+          </a:fillRef>
+          <a:effectRef idx="2">
+            <a:schemeClr val="accent1"/>
+          </a:effectRef>
+          <a:fontRef idx="minor">
+            <a:schemeClr val="lt1"/>
+          </a:fontRef>
+        </p:style>
+        <p:txBody>
+          <a:bodyPr rtlCol="0" anchor="ctr"/>
+          <a:lstStyle/>
+          <a:p>
+            <a:pPr algn="ctr"/>
+          </a:p>
+        </p:txBody>
+      </p:sp>
+      <p:sp>
+        <p:nvSpPr>
+          <p:cNvPr id="11" name="TextBox 10"/>
+          <p:cNvSpPr txBox="1"/>
+          <p:nvPr/>
+        </p:nvSpPr>
+        <p:spPr>
+          <a:xfrm>
+            <a:off x="6428232" y="5632704"/>
+            <a:ext cx="5120640" cy="658368"/>
+          </a:xfrm>
+          <a:prstGeom prst="rect">
+            <a:avLst/>
+          </a:prstGeom>
+          <a:noFill/>
+        </p:spPr>
+        <p:txBody>
+          <a:bodyPr wrap="square" anchor="t">
+            <a:spAutoFit/>
+          </a:bodyPr>
+          <a:lstStyle/>
+          <a:p>
+            <a:pPr algn="l">
+              <a:spcAft>
+                <a:spcPts val="400"/>
+              </a:spcAft>
+            </a:pPr>
+            <a:r>
+              <a:rPr sz="1050" b="1" i="0">
+                <a:solidFill>
+                  <a:srgbClr val="1F7A4D"/>
+                </a:solidFill>
+                <a:latin typeface="Segoe UI"/>
+              </a:rPr>
+              <a:t>🎯 PROJEDEKİ ROLÜ</a:t>
+            </a:r>
+          </a:p>
+          <a:p>
+            <a:pPr algn="l">
+              <a:spcAft>
+                <a:spcPts val="400"/>
+              </a:spcAft>
+            </a:pPr>
+            <a:r>
+              <a:rPr sz="1300" b="1" i="0">
+                <a:solidFill>
+                  <a:srgbClr val="1F3B57"/>
+                </a:solidFill>
+                <a:latin typeface="Segoe UI"/>
+              </a:rPr>
+              <a:t>6 duygu olasılığı; en yüksek = tahmin</a:t>
+            </a:r>
+          </a:p>
+        </p:txBody>
+      </p:sp>
+      <p:sp>
+        <p:nvSpPr>
+          <p:cNvPr id="12" name="Rectangle 11"/>
           <p:cNvSpPr/>
           <p:nvPr/>
         </p:nvSpPr>
@@ -6829,7 +8279,7 @@
       </p:sp>
       <p:sp>
         <p:nvSpPr>
-          <p:cNvPr id="7" name="TextBox 6"/>
+          <p:cNvPr id="13" name="TextBox 12"/>
           <p:cNvSpPr txBox="1"/>
           <p:nvPr/>
         </p:nvSpPr>
@@ -6868,7 +8318,7 @@
       </p:sp>
       <p:sp>
         <p:nvSpPr>
-          <p:cNvPr id="8" name="TextBox 7"/>
+          <p:cNvPr id="14" name="TextBox 13"/>
           <p:cNvSpPr txBox="1"/>
           <p:nvPr/>
         </p:nvSpPr>
@@ -8275,8 +9725,8 @@
         </p:blipFill>
         <p:spPr>
           <a:xfrm>
-            <a:off x="1066647" y="1554480"/>
-            <a:ext cx="10058400" cy="4023360"/>
+            <a:off x="1340967" y="1371600"/>
+            <a:ext cx="9509760" cy="3803904"/>
           </a:xfrm>
           <a:prstGeom prst="rect">
             <a:avLst/>
@@ -8285,7 +9735,297 @@
       </p:pic>
       <p:sp>
         <p:nvSpPr>
-          <p:cNvPr id="6" name="Rectangle 5"/>
+          <p:cNvPr id="6" name="Rounded Rectangle 5"/>
+          <p:cNvSpPr/>
+          <p:nvPr/>
+        </p:nvSpPr>
+        <p:spPr>
+          <a:xfrm>
+            <a:off x="548640" y="5577840"/>
+            <a:ext cx="5440680" cy="777240"/>
+          </a:xfrm>
+          <a:prstGeom prst="roundRect">
+            <a:avLst>
+              <a:gd name="adj" fmla="val 8000"/>
+            </a:avLst>
+          </a:prstGeom>
+          <a:solidFill>
+            <a:srgbClr val="E8F1FA"/>
+          </a:solidFill>
+          <a:ln>
+            <a:noFill/>
+          </a:ln>
+          <a:effectLst/>
+        </p:spPr>
+        <p:style>
+          <a:lnRef idx="1">
+            <a:schemeClr val="accent1"/>
+          </a:lnRef>
+          <a:fillRef idx="3">
+            <a:schemeClr val="accent1"/>
+          </a:fillRef>
+          <a:effectRef idx="2">
+            <a:schemeClr val="accent1"/>
+          </a:effectRef>
+          <a:fontRef idx="minor">
+            <a:schemeClr val="lt1"/>
+          </a:fontRef>
+        </p:style>
+        <p:txBody>
+          <a:bodyPr rtlCol="0" anchor="ctr"/>
+          <a:lstStyle/>
+          <a:p>
+            <a:pPr algn="ctr"/>
+          </a:p>
+        </p:txBody>
+      </p:sp>
+      <p:sp>
+        <p:nvSpPr>
+          <p:cNvPr id="7" name="Rectangle 6"/>
+          <p:cNvSpPr/>
+          <p:nvPr/>
+        </p:nvSpPr>
+        <p:spPr>
+          <a:xfrm>
+            <a:off x="548640" y="5577840"/>
+            <a:ext cx="82296" cy="777240"/>
+          </a:xfrm>
+          <a:prstGeom prst="rect">
+            <a:avLst/>
+          </a:prstGeom>
+          <a:solidFill>
+            <a:srgbClr val="2F74C0"/>
+          </a:solidFill>
+          <a:ln>
+            <a:noFill/>
+          </a:ln>
+          <a:effectLst/>
+        </p:spPr>
+        <p:style>
+          <a:lnRef idx="1">
+            <a:schemeClr val="accent1"/>
+          </a:lnRef>
+          <a:fillRef idx="3">
+            <a:schemeClr val="accent1"/>
+          </a:fillRef>
+          <a:effectRef idx="2">
+            <a:schemeClr val="accent1"/>
+          </a:effectRef>
+          <a:fontRef idx="minor">
+            <a:schemeClr val="lt1"/>
+          </a:fontRef>
+        </p:style>
+        <p:txBody>
+          <a:bodyPr rtlCol="0" anchor="ctr"/>
+          <a:lstStyle/>
+          <a:p>
+            <a:pPr algn="ctr"/>
+          </a:p>
+        </p:txBody>
+      </p:sp>
+      <p:sp>
+        <p:nvSpPr>
+          <p:cNvPr id="8" name="TextBox 7"/>
+          <p:cNvSpPr txBox="1"/>
+          <p:nvPr/>
+        </p:nvSpPr>
+        <p:spPr>
+          <a:xfrm>
+            <a:off x="777240" y="5632704"/>
+            <a:ext cx="5120640" cy="658368"/>
+          </a:xfrm>
+          <a:prstGeom prst="rect">
+            <a:avLst/>
+          </a:prstGeom>
+          <a:noFill/>
+        </p:spPr>
+        <p:txBody>
+          <a:bodyPr wrap="square" anchor="t">
+            <a:spAutoFit/>
+          </a:bodyPr>
+          <a:lstStyle/>
+          <a:p>
+            <a:pPr algn="l">
+              <a:spcAft>
+                <a:spcPts val="400"/>
+              </a:spcAft>
+            </a:pPr>
+            <a:r>
+              <a:rPr sz="1050" b="1" i="0">
+                <a:solidFill>
+                  <a:srgbClr val="2F74C0"/>
+                </a:solidFill>
+                <a:latin typeface="Segoe UI"/>
+              </a:rPr>
+              <a:t>⚙ NASIL ÇALIŞIR</a:t>
+            </a:r>
+          </a:p>
+          <a:p>
+            <a:pPr algn="l">
+              <a:spcAft>
+                <a:spcPts val="400"/>
+              </a:spcAft>
+            </a:pPr>
+            <a:r>
+              <a:rPr sz="1300" b="1" i="0">
+                <a:solidFill>
+                  <a:srgbClr val="1F3B57"/>
+                </a:solidFill>
+                <a:latin typeface="Segoe UI"/>
+              </a:rPr>
+              <a:t>8 epoch iyileşme yok → dur, ★'a dön</a:t>
+            </a:r>
+          </a:p>
+        </p:txBody>
+      </p:sp>
+      <p:sp>
+        <p:nvSpPr>
+          <p:cNvPr id="9" name="Rounded Rectangle 8"/>
+          <p:cNvSpPr/>
+          <p:nvPr/>
+        </p:nvSpPr>
+        <p:spPr>
+          <a:xfrm>
+            <a:off x="6199632" y="5577840"/>
+            <a:ext cx="5440680" cy="777240"/>
+          </a:xfrm>
+          <a:prstGeom prst="roundRect">
+            <a:avLst>
+              <a:gd name="adj" fmla="val 8000"/>
+            </a:avLst>
+          </a:prstGeom>
+          <a:solidFill>
+            <a:srgbClr val="E9F6EF"/>
+          </a:solidFill>
+          <a:ln>
+            <a:noFill/>
+          </a:ln>
+          <a:effectLst/>
+        </p:spPr>
+        <p:style>
+          <a:lnRef idx="1">
+            <a:schemeClr val="accent1"/>
+          </a:lnRef>
+          <a:fillRef idx="3">
+            <a:schemeClr val="accent1"/>
+          </a:fillRef>
+          <a:effectRef idx="2">
+            <a:schemeClr val="accent1"/>
+          </a:effectRef>
+          <a:fontRef idx="minor">
+            <a:schemeClr val="lt1"/>
+          </a:fontRef>
+        </p:style>
+        <p:txBody>
+          <a:bodyPr rtlCol="0" anchor="ctr"/>
+          <a:lstStyle/>
+          <a:p>
+            <a:pPr algn="ctr"/>
+          </a:p>
+        </p:txBody>
+      </p:sp>
+      <p:sp>
+        <p:nvSpPr>
+          <p:cNvPr id="10" name="Rectangle 9"/>
+          <p:cNvSpPr/>
+          <p:nvPr/>
+        </p:nvSpPr>
+        <p:spPr>
+          <a:xfrm>
+            <a:off x="6199632" y="5577840"/>
+            <a:ext cx="82296" cy="777240"/>
+          </a:xfrm>
+          <a:prstGeom prst="rect">
+            <a:avLst/>
+          </a:prstGeom>
+          <a:solidFill>
+            <a:srgbClr val="1F7A4D"/>
+          </a:solidFill>
+          <a:ln>
+            <a:noFill/>
+          </a:ln>
+          <a:effectLst/>
+        </p:spPr>
+        <p:style>
+          <a:lnRef idx="1">
+            <a:schemeClr val="accent1"/>
+          </a:lnRef>
+          <a:fillRef idx="3">
+            <a:schemeClr val="accent1"/>
+          </a:fillRef>
+          <a:effectRef idx="2">
+            <a:schemeClr val="accent1"/>
+          </a:effectRef>
+          <a:fontRef idx="minor">
+            <a:schemeClr val="lt1"/>
+          </a:fontRef>
+        </p:style>
+        <p:txBody>
+          <a:bodyPr rtlCol="0" anchor="ctr"/>
+          <a:lstStyle/>
+          <a:p>
+            <a:pPr algn="ctr"/>
+          </a:p>
+        </p:txBody>
+      </p:sp>
+      <p:sp>
+        <p:nvSpPr>
+          <p:cNvPr id="11" name="TextBox 10"/>
+          <p:cNvSpPr txBox="1"/>
+          <p:nvPr/>
+        </p:nvSpPr>
+        <p:spPr>
+          <a:xfrm>
+            <a:off x="6428232" y="5632704"/>
+            <a:ext cx="5120640" cy="658368"/>
+          </a:xfrm>
+          <a:prstGeom prst="rect">
+            <a:avLst/>
+          </a:prstGeom>
+          <a:noFill/>
+        </p:spPr>
+        <p:txBody>
+          <a:bodyPr wrap="square" anchor="t">
+            <a:spAutoFit/>
+          </a:bodyPr>
+          <a:lstStyle/>
+          <a:p>
+            <a:pPr algn="l">
+              <a:spcAft>
+                <a:spcPts val="400"/>
+              </a:spcAft>
+            </a:pPr>
+            <a:r>
+              <a:rPr sz="1050" b="1" i="0">
+                <a:solidFill>
+                  <a:srgbClr val="1F7A4D"/>
+                </a:solidFill>
+                <a:latin typeface="Segoe UI"/>
+              </a:rPr>
+              <a:t>🎯 PROJEDEKİ ROLÜ</a:t>
+            </a:r>
+          </a:p>
+          <a:p>
+            <a:pPr algn="l">
+              <a:spcAft>
+                <a:spcPts val="400"/>
+              </a:spcAft>
+            </a:pPr>
+            <a:r>
+              <a:rPr sz="1300" b="1" i="0">
+                <a:solidFill>
+                  <a:srgbClr val="1F3B57"/>
+                </a:solidFill>
+                <a:latin typeface="Segoe UI"/>
+              </a:rPr>
+              <a:t>Ezberi kesti (CNN: 37 koştu, 29 seçildi)</a:t>
+            </a:r>
+          </a:p>
+        </p:txBody>
+      </p:sp>
+      <p:sp>
+        <p:nvSpPr>
+          <p:cNvPr id="12" name="Rectangle 11"/>
           <p:cNvSpPr/>
           <p:nvPr/>
         </p:nvSpPr>
@@ -8329,7 +10069,7 @@
       </p:sp>
       <p:sp>
         <p:nvSpPr>
-          <p:cNvPr id="7" name="TextBox 6"/>
+          <p:cNvPr id="13" name="TextBox 12"/>
           <p:cNvSpPr txBox="1"/>
           <p:nvPr/>
         </p:nvSpPr>
@@ -8368,7 +10108,7 @@
       </p:sp>
       <p:sp>
         <p:nvSpPr>
-          <p:cNvPr id="8" name="TextBox 7"/>
+          <p:cNvPr id="14" name="TextBox 13"/>
           <p:cNvSpPr txBox="1"/>
           <p:nvPr/>
         </p:nvSpPr>
@@ -9662,8 +11402,8 @@
         </p:blipFill>
         <p:spPr>
           <a:xfrm>
-            <a:off x="1295247" y="1645920"/>
-            <a:ext cx="9601200" cy="3627120"/>
+            <a:off x="1523847" y="1371600"/>
+            <a:ext cx="9144000" cy="3454400"/>
           </a:xfrm>
           <a:prstGeom prst="rect">
             <a:avLst/>
@@ -9672,7 +11412,297 @@
       </p:pic>
       <p:sp>
         <p:nvSpPr>
-          <p:cNvPr id="6" name="Rectangle 5"/>
+          <p:cNvPr id="6" name="Rounded Rectangle 5"/>
+          <p:cNvSpPr/>
+          <p:nvPr/>
+        </p:nvSpPr>
+        <p:spPr>
+          <a:xfrm>
+            <a:off x="548640" y="5577840"/>
+            <a:ext cx="5440680" cy="777240"/>
+          </a:xfrm>
+          <a:prstGeom prst="roundRect">
+            <a:avLst>
+              <a:gd name="adj" fmla="val 8000"/>
+            </a:avLst>
+          </a:prstGeom>
+          <a:solidFill>
+            <a:srgbClr val="E8F1FA"/>
+          </a:solidFill>
+          <a:ln>
+            <a:noFill/>
+          </a:ln>
+          <a:effectLst/>
+        </p:spPr>
+        <p:style>
+          <a:lnRef idx="1">
+            <a:schemeClr val="accent1"/>
+          </a:lnRef>
+          <a:fillRef idx="3">
+            <a:schemeClr val="accent1"/>
+          </a:fillRef>
+          <a:effectRef idx="2">
+            <a:schemeClr val="accent1"/>
+          </a:effectRef>
+          <a:fontRef idx="minor">
+            <a:schemeClr val="lt1"/>
+          </a:fontRef>
+        </p:style>
+        <p:txBody>
+          <a:bodyPr rtlCol="0" anchor="ctr"/>
+          <a:lstStyle/>
+          <a:p>
+            <a:pPr algn="ctr"/>
+          </a:p>
+        </p:txBody>
+      </p:sp>
+      <p:sp>
+        <p:nvSpPr>
+          <p:cNvPr id="7" name="Rectangle 6"/>
+          <p:cNvSpPr/>
+          <p:nvPr/>
+        </p:nvSpPr>
+        <p:spPr>
+          <a:xfrm>
+            <a:off x="548640" y="5577840"/>
+            <a:ext cx="82296" cy="777240"/>
+          </a:xfrm>
+          <a:prstGeom prst="rect">
+            <a:avLst/>
+          </a:prstGeom>
+          <a:solidFill>
+            <a:srgbClr val="2F74C0"/>
+          </a:solidFill>
+          <a:ln>
+            <a:noFill/>
+          </a:ln>
+          <a:effectLst/>
+        </p:spPr>
+        <p:style>
+          <a:lnRef idx="1">
+            <a:schemeClr val="accent1"/>
+          </a:lnRef>
+          <a:fillRef idx="3">
+            <a:schemeClr val="accent1"/>
+          </a:fillRef>
+          <a:effectRef idx="2">
+            <a:schemeClr val="accent1"/>
+          </a:effectRef>
+          <a:fontRef idx="minor">
+            <a:schemeClr val="lt1"/>
+          </a:fontRef>
+        </p:style>
+        <p:txBody>
+          <a:bodyPr rtlCol="0" anchor="ctr"/>
+          <a:lstStyle/>
+          <a:p>
+            <a:pPr algn="ctr"/>
+          </a:p>
+        </p:txBody>
+      </p:sp>
+      <p:sp>
+        <p:nvSpPr>
+          <p:cNvPr id="8" name="TextBox 7"/>
+          <p:cNvSpPr txBox="1"/>
+          <p:nvPr/>
+        </p:nvSpPr>
+        <p:spPr>
+          <a:xfrm>
+            <a:off x="777240" y="5632704"/>
+            <a:ext cx="5120640" cy="658368"/>
+          </a:xfrm>
+          <a:prstGeom prst="rect">
+            <a:avLst/>
+          </a:prstGeom>
+          <a:noFill/>
+        </p:spPr>
+        <p:txBody>
+          <a:bodyPr wrap="square" anchor="t">
+            <a:spAutoFit/>
+          </a:bodyPr>
+          <a:lstStyle/>
+          <a:p>
+            <a:pPr algn="l">
+              <a:spcAft>
+                <a:spcPts val="400"/>
+              </a:spcAft>
+            </a:pPr>
+            <a:r>
+              <a:rPr sz="1050" b="1" i="0">
+                <a:solidFill>
+                  <a:srgbClr val="2F74C0"/>
+                </a:solidFill>
+                <a:latin typeface="Segoe UI"/>
+              </a:rPr>
+              <a:t>⚙ NASIL ÇALIŞIR</a:t>
+            </a:r>
+          </a:p>
+          <a:p>
+            <a:pPr algn="l">
+              <a:spcAft>
+                <a:spcPts val="400"/>
+              </a:spcAft>
+            </a:pPr>
+            <a:r>
+              <a:rPr sz="1300" b="1" i="0">
+                <a:solidFill>
+                  <a:srgbClr val="1F3B57"/>
+                </a:solidFill>
+                <a:latin typeface="Segoe UI"/>
+              </a:rPr>
+              <a:t>Doğruluk çoğunluğa kanar</a:t>
+            </a:r>
+          </a:p>
+        </p:txBody>
+      </p:sp>
+      <p:sp>
+        <p:nvSpPr>
+          <p:cNvPr id="9" name="Rounded Rectangle 8"/>
+          <p:cNvSpPr/>
+          <p:nvPr/>
+        </p:nvSpPr>
+        <p:spPr>
+          <a:xfrm>
+            <a:off x="6199632" y="5577840"/>
+            <a:ext cx="5440680" cy="777240"/>
+          </a:xfrm>
+          <a:prstGeom prst="roundRect">
+            <a:avLst>
+              <a:gd name="adj" fmla="val 8000"/>
+            </a:avLst>
+          </a:prstGeom>
+          <a:solidFill>
+            <a:srgbClr val="E9F6EF"/>
+          </a:solidFill>
+          <a:ln>
+            <a:noFill/>
+          </a:ln>
+          <a:effectLst/>
+        </p:spPr>
+        <p:style>
+          <a:lnRef idx="1">
+            <a:schemeClr val="accent1"/>
+          </a:lnRef>
+          <a:fillRef idx="3">
+            <a:schemeClr val="accent1"/>
+          </a:fillRef>
+          <a:effectRef idx="2">
+            <a:schemeClr val="accent1"/>
+          </a:effectRef>
+          <a:fontRef idx="minor">
+            <a:schemeClr val="lt1"/>
+          </a:fontRef>
+        </p:style>
+        <p:txBody>
+          <a:bodyPr rtlCol="0" anchor="ctr"/>
+          <a:lstStyle/>
+          <a:p>
+            <a:pPr algn="ctr"/>
+          </a:p>
+        </p:txBody>
+      </p:sp>
+      <p:sp>
+        <p:nvSpPr>
+          <p:cNvPr id="10" name="Rectangle 9"/>
+          <p:cNvSpPr/>
+          <p:nvPr/>
+        </p:nvSpPr>
+        <p:spPr>
+          <a:xfrm>
+            <a:off x="6199632" y="5577840"/>
+            <a:ext cx="82296" cy="777240"/>
+          </a:xfrm>
+          <a:prstGeom prst="rect">
+            <a:avLst/>
+          </a:prstGeom>
+          <a:solidFill>
+            <a:srgbClr val="1F7A4D"/>
+          </a:solidFill>
+          <a:ln>
+            <a:noFill/>
+          </a:ln>
+          <a:effectLst/>
+        </p:spPr>
+        <p:style>
+          <a:lnRef idx="1">
+            <a:schemeClr val="accent1"/>
+          </a:lnRef>
+          <a:fillRef idx="3">
+            <a:schemeClr val="accent1"/>
+          </a:fillRef>
+          <a:effectRef idx="2">
+            <a:schemeClr val="accent1"/>
+          </a:effectRef>
+          <a:fontRef idx="minor">
+            <a:schemeClr val="lt1"/>
+          </a:fontRef>
+        </p:style>
+        <p:txBody>
+          <a:bodyPr rtlCol="0" anchor="ctr"/>
+          <a:lstStyle/>
+          <a:p>
+            <a:pPr algn="ctr"/>
+          </a:p>
+        </p:txBody>
+      </p:sp>
+      <p:sp>
+        <p:nvSpPr>
+          <p:cNvPr id="11" name="TextBox 10"/>
+          <p:cNvSpPr txBox="1"/>
+          <p:nvPr/>
+        </p:nvSpPr>
+        <p:spPr>
+          <a:xfrm>
+            <a:off x="6428232" y="5632704"/>
+            <a:ext cx="5120640" cy="658368"/>
+          </a:xfrm>
+          <a:prstGeom prst="rect">
+            <a:avLst/>
+          </a:prstGeom>
+          <a:noFill/>
+        </p:spPr>
+        <p:txBody>
+          <a:bodyPr wrap="square" anchor="t">
+            <a:spAutoFit/>
+          </a:bodyPr>
+          <a:lstStyle/>
+          <a:p>
+            <a:pPr algn="l">
+              <a:spcAft>
+                <a:spcPts val="400"/>
+              </a:spcAft>
+            </a:pPr>
+            <a:r>
+              <a:rPr sz="1050" b="1" i="0">
+                <a:solidFill>
+                  <a:srgbClr val="1F7A4D"/>
+                </a:solidFill>
+                <a:latin typeface="Segoe UI"/>
+              </a:rPr>
+              <a:t>🎯 PROJEDEKİ ROLÜ</a:t>
+            </a:r>
+          </a:p>
+          <a:p>
+            <a:pPr algn="l">
+              <a:spcAft>
+                <a:spcPts val="400"/>
+              </a:spcAft>
+            </a:pPr>
+            <a:r>
+              <a:rPr sz="1300" b="1" i="0">
+                <a:solidFill>
+                  <a:srgbClr val="1F3B57"/>
+                </a:solidFill>
+                <a:latin typeface="Segoe UI"/>
+              </a:rPr>
+              <a:t>Model seçimini macro-F1 ile yaptık</a:t>
+            </a:r>
+          </a:p>
+        </p:txBody>
+      </p:sp>
+      <p:sp>
+        <p:nvSpPr>
+          <p:cNvPr id="12" name="Rectangle 11"/>
           <p:cNvSpPr/>
           <p:nvPr/>
         </p:nvSpPr>
@@ -9716,7 +11746,7 @@
       </p:sp>
       <p:sp>
         <p:nvSpPr>
-          <p:cNvPr id="7" name="TextBox 6"/>
+          <p:cNvPr id="13" name="TextBox 12"/>
           <p:cNvSpPr txBox="1"/>
           <p:nvPr/>
         </p:nvSpPr>
@@ -9755,7 +11785,7 @@
       </p:sp>
       <p:sp>
         <p:nvSpPr>
-          <p:cNvPr id="8" name="TextBox 7"/>
+          <p:cNvPr id="14" name="TextBox 13"/>
           <p:cNvSpPr txBox="1"/>
           <p:nvPr/>
         </p:nvSpPr>
@@ -17005,8 +19035,8 @@
         </p:blipFill>
         <p:spPr>
           <a:xfrm>
-            <a:off x="1249527" y="1371600"/>
-            <a:ext cx="9692640" cy="4307840"/>
+            <a:off x="1706727" y="1280160"/>
+            <a:ext cx="8778240" cy="3901440"/>
           </a:xfrm>
           <a:prstGeom prst="rect">
             <a:avLst/>
@@ -17015,7 +19045,297 @@
       </p:pic>
       <p:sp>
         <p:nvSpPr>
-          <p:cNvPr id="6" name="Rectangle 5"/>
+          <p:cNvPr id="6" name="Rounded Rectangle 5"/>
+          <p:cNvSpPr/>
+          <p:nvPr/>
+        </p:nvSpPr>
+        <p:spPr>
+          <a:xfrm>
+            <a:off x="548640" y="5577840"/>
+            <a:ext cx="5440680" cy="777240"/>
+          </a:xfrm>
+          <a:prstGeom prst="roundRect">
+            <a:avLst>
+              <a:gd name="adj" fmla="val 8000"/>
+            </a:avLst>
+          </a:prstGeom>
+          <a:solidFill>
+            <a:srgbClr val="E8F1FA"/>
+          </a:solidFill>
+          <a:ln>
+            <a:noFill/>
+          </a:ln>
+          <a:effectLst/>
+        </p:spPr>
+        <p:style>
+          <a:lnRef idx="1">
+            <a:schemeClr val="accent1"/>
+          </a:lnRef>
+          <a:fillRef idx="3">
+            <a:schemeClr val="accent1"/>
+          </a:fillRef>
+          <a:effectRef idx="2">
+            <a:schemeClr val="accent1"/>
+          </a:effectRef>
+          <a:fontRef idx="minor">
+            <a:schemeClr val="lt1"/>
+          </a:fontRef>
+        </p:style>
+        <p:txBody>
+          <a:bodyPr rtlCol="0" anchor="ctr"/>
+          <a:lstStyle/>
+          <a:p>
+            <a:pPr algn="ctr"/>
+          </a:p>
+        </p:txBody>
+      </p:sp>
+      <p:sp>
+        <p:nvSpPr>
+          <p:cNvPr id="7" name="Rectangle 6"/>
+          <p:cNvSpPr/>
+          <p:nvPr/>
+        </p:nvSpPr>
+        <p:spPr>
+          <a:xfrm>
+            <a:off x="548640" y="5577840"/>
+            <a:ext cx="82296" cy="777240"/>
+          </a:xfrm>
+          <a:prstGeom prst="rect">
+            <a:avLst/>
+          </a:prstGeom>
+          <a:solidFill>
+            <a:srgbClr val="2F74C0"/>
+          </a:solidFill>
+          <a:ln>
+            <a:noFill/>
+          </a:ln>
+          <a:effectLst/>
+        </p:spPr>
+        <p:style>
+          <a:lnRef idx="1">
+            <a:schemeClr val="accent1"/>
+          </a:lnRef>
+          <a:fillRef idx="3">
+            <a:schemeClr val="accent1"/>
+          </a:fillRef>
+          <a:effectRef idx="2">
+            <a:schemeClr val="accent1"/>
+          </a:effectRef>
+          <a:fontRef idx="minor">
+            <a:schemeClr val="lt1"/>
+          </a:fontRef>
+        </p:style>
+        <p:txBody>
+          <a:bodyPr rtlCol="0" anchor="ctr"/>
+          <a:lstStyle/>
+          <a:p>
+            <a:pPr algn="ctr"/>
+          </a:p>
+        </p:txBody>
+      </p:sp>
+      <p:sp>
+        <p:nvSpPr>
+          <p:cNvPr id="8" name="TextBox 7"/>
+          <p:cNvSpPr txBox="1"/>
+          <p:nvPr/>
+        </p:nvSpPr>
+        <p:spPr>
+          <a:xfrm>
+            <a:off x="777240" y="5632704"/>
+            <a:ext cx="5120640" cy="658368"/>
+          </a:xfrm>
+          <a:prstGeom prst="rect">
+            <a:avLst/>
+          </a:prstGeom>
+          <a:noFill/>
+        </p:spPr>
+        <p:txBody>
+          <a:bodyPr wrap="square" anchor="t">
+            <a:spAutoFit/>
+          </a:bodyPr>
+          <a:lstStyle/>
+          <a:p>
+            <a:pPr algn="l">
+              <a:spcAft>
+                <a:spcPts val="400"/>
+              </a:spcAft>
+            </a:pPr>
+            <a:r>
+              <a:rPr sz="1050" b="1" i="0">
+                <a:solidFill>
+                  <a:srgbClr val="2F74C0"/>
+                </a:solidFill>
+                <a:latin typeface="Segoe UI"/>
+              </a:rPr>
+              <a:t>⚙ NASIL ÇALIŞIR</a:t>
+            </a:r>
+          </a:p>
+          <a:p>
+            <a:pPr algn="l">
+              <a:spcAft>
+                <a:spcPts val="400"/>
+              </a:spcAft>
+            </a:pPr>
+            <a:r>
+              <a:rPr sz="1300" b="1" i="0">
+                <a:solidFill>
+                  <a:srgbClr val="1F3B57"/>
+                </a:solidFill>
+                <a:latin typeface="Segoe UI"/>
+              </a:rPr>
+              <a:t>Aktörün TÜM kayıtları tek kutuya</a:t>
+            </a:r>
+          </a:p>
+        </p:txBody>
+      </p:sp>
+      <p:sp>
+        <p:nvSpPr>
+          <p:cNvPr id="9" name="Rounded Rectangle 8"/>
+          <p:cNvSpPr/>
+          <p:nvPr/>
+        </p:nvSpPr>
+        <p:spPr>
+          <a:xfrm>
+            <a:off x="6199632" y="5577840"/>
+            <a:ext cx="5440680" cy="777240"/>
+          </a:xfrm>
+          <a:prstGeom prst="roundRect">
+            <a:avLst>
+              <a:gd name="adj" fmla="val 8000"/>
+            </a:avLst>
+          </a:prstGeom>
+          <a:solidFill>
+            <a:srgbClr val="E9F6EF"/>
+          </a:solidFill>
+          <a:ln>
+            <a:noFill/>
+          </a:ln>
+          <a:effectLst/>
+        </p:spPr>
+        <p:style>
+          <a:lnRef idx="1">
+            <a:schemeClr val="accent1"/>
+          </a:lnRef>
+          <a:fillRef idx="3">
+            <a:schemeClr val="accent1"/>
+          </a:fillRef>
+          <a:effectRef idx="2">
+            <a:schemeClr val="accent1"/>
+          </a:effectRef>
+          <a:fontRef idx="minor">
+            <a:schemeClr val="lt1"/>
+          </a:fontRef>
+        </p:style>
+        <p:txBody>
+          <a:bodyPr rtlCol="0" anchor="ctr"/>
+          <a:lstStyle/>
+          <a:p>
+            <a:pPr algn="ctr"/>
+          </a:p>
+        </p:txBody>
+      </p:sp>
+      <p:sp>
+        <p:nvSpPr>
+          <p:cNvPr id="10" name="Rectangle 9"/>
+          <p:cNvSpPr/>
+          <p:nvPr/>
+        </p:nvSpPr>
+        <p:spPr>
+          <a:xfrm>
+            <a:off x="6199632" y="5577840"/>
+            <a:ext cx="82296" cy="777240"/>
+          </a:xfrm>
+          <a:prstGeom prst="rect">
+            <a:avLst/>
+          </a:prstGeom>
+          <a:solidFill>
+            <a:srgbClr val="1F7A4D"/>
+          </a:solidFill>
+          <a:ln>
+            <a:noFill/>
+          </a:ln>
+          <a:effectLst/>
+        </p:spPr>
+        <p:style>
+          <a:lnRef idx="1">
+            <a:schemeClr val="accent1"/>
+          </a:lnRef>
+          <a:fillRef idx="3">
+            <a:schemeClr val="accent1"/>
+          </a:fillRef>
+          <a:effectRef idx="2">
+            <a:schemeClr val="accent1"/>
+          </a:effectRef>
+          <a:fontRef idx="minor">
+            <a:schemeClr val="lt1"/>
+          </a:fontRef>
+        </p:style>
+        <p:txBody>
+          <a:bodyPr rtlCol="0" anchor="ctr"/>
+          <a:lstStyle/>
+          <a:p>
+            <a:pPr algn="ctr"/>
+          </a:p>
+        </p:txBody>
+      </p:sp>
+      <p:sp>
+        <p:nvSpPr>
+          <p:cNvPr id="11" name="TextBox 10"/>
+          <p:cNvSpPr txBox="1"/>
+          <p:nvPr/>
+        </p:nvSpPr>
+        <p:spPr>
+          <a:xfrm>
+            <a:off x="6428232" y="5632704"/>
+            <a:ext cx="5120640" cy="658368"/>
+          </a:xfrm>
+          <a:prstGeom prst="rect">
+            <a:avLst/>
+          </a:prstGeom>
+          <a:noFill/>
+        </p:spPr>
+        <p:txBody>
+          <a:bodyPr wrap="square" anchor="t">
+            <a:spAutoFit/>
+          </a:bodyPr>
+          <a:lstStyle/>
+          <a:p>
+            <a:pPr algn="l">
+              <a:spcAft>
+                <a:spcPts val="400"/>
+              </a:spcAft>
+            </a:pPr>
+            <a:r>
+              <a:rPr sz="1050" b="1" i="0">
+                <a:solidFill>
+                  <a:srgbClr val="1F7A4D"/>
+                </a:solidFill>
+                <a:latin typeface="Segoe UI"/>
+              </a:rPr>
+              <a:t>🎯 PROJEDEKİ ROLÜ</a:t>
+            </a:r>
+          </a:p>
+          <a:p>
+            <a:pPr algn="l">
+              <a:spcAft>
+                <a:spcPts val="400"/>
+              </a:spcAft>
+            </a:pPr>
+            <a:r>
+              <a:rPr sz="1300" b="1" i="0">
+                <a:solidFill>
+                  <a:srgbClr val="1F3B57"/>
+                </a:solidFill>
+                <a:latin typeface="Segoe UI"/>
+              </a:rPr>
+              <a:t>Ses ezberi imkânsız → skor gerçek</a:t>
+            </a:r>
+          </a:p>
+        </p:txBody>
+      </p:sp>
+      <p:sp>
+        <p:nvSpPr>
+          <p:cNvPr id="12" name="Rectangle 11"/>
           <p:cNvSpPr/>
           <p:nvPr/>
         </p:nvSpPr>
@@ -17059,7 +19379,7 @@
       </p:sp>
       <p:sp>
         <p:nvSpPr>
-          <p:cNvPr id="7" name="TextBox 6"/>
+          <p:cNvPr id="13" name="TextBox 12"/>
           <p:cNvSpPr txBox="1"/>
           <p:nvPr/>
         </p:nvSpPr>
@@ -17098,7 +19418,7 @@
       </p:sp>
       <p:sp>
         <p:nvSpPr>
-          <p:cNvPr id="8" name="TextBox 7"/>
+          <p:cNvPr id="14" name="TextBox 13"/>
           <p:cNvSpPr txBox="1"/>
           <p:nvPr/>
         </p:nvSpPr>
@@ -18387,8 +20707,8 @@
         </p:blipFill>
         <p:spPr>
           <a:xfrm>
-            <a:off x="1295247" y="1371600"/>
-            <a:ext cx="9601200" cy="4693920"/>
+            <a:off x="1889607" y="1325880"/>
+            <a:ext cx="8412480" cy="4112768"/>
           </a:xfrm>
           <a:prstGeom prst="rect">
             <a:avLst/>
@@ -18397,7 +20717,297 @@
       </p:pic>
       <p:sp>
         <p:nvSpPr>
-          <p:cNvPr id="6" name="Rectangle 5"/>
+          <p:cNvPr id="6" name="Rounded Rectangle 5"/>
+          <p:cNvSpPr/>
+          <p:nvPr/>
+        </p:nvSpPr>
+        <p:spPr>
+          <a:xfrm>
+            <a:off x="548640" y="5577840"/>
+            <a:ext cx="5440680" cy="777240"/>
+          </a:xfrm>
+          <a:prstGeom prst="roundRect">
+            <a:avLst>
+              <a:gd name="adj" fmla="val 8000"/>
+            </a:avLst>
+          </a:prstGeom>
+          <a:solidFill>
+            <a:srgbClr val="E8F1FA"/>
+          </a:solidFill>
+          <a:ln>
+            <a:noFill/>
+          </a:ln>
+          <a:effectLst/>
+        </p:spPr>
+        <p:style>
+          <a:lnRef idx="1">
+            <a:schemeClr val="accent1"/>
+          </a:lnRef>
+          <a:fillRef idx="3">
+            <a:schemeClr val="accent1"/>
+          </a:fillRef>
+          <a:effectRef idx="2">
+            <a:schemeClr val="accent1"/>
+          </a:effectRef>
+          <a:fontRef idx="minor">
+            <a:schemeClr val="lt1"/>
+          </a:fontRef>
+        </p:style>
+        <p:txBody>
+          <a:bodyPr rtlCol="0" anchor="ctr"/>
+          <a:lstStyle/>
+          <a:p>
+            <a:pPr algn="ctr"/>
+          </a:p>
+        </p:txBody>
+      </p:sp>
+      <p:sp>
+        <p:nvSpPr>
+          <p:cNvPr id="7" name="Rectangle 6"/>
+          <p:cNvSpPr/>
+          <p:nvPr/>
+        </p:nvSpPr>
+        <p:spPr>
+          <a:xfrm>
+            <a:off x="548640" y="5577840"/>
+            <a:ext cx="82296" cy="777240"/>
+          </a:xfrm>
+          <a:prstGeom prst="rect">
+            <a:avLst/>
+          </a:prstGeom>
+          <a:solidFill>
+            <a:srgbClr val="2F74C0"/>
+          </a:solidFill>
+          <a:ln>
+            <a:noFill/>
+          </a:ln>
+          <a:effectLst/>
+        </p:spPr>
+        <p:style>
+          <a:lnRef idx="1">
+            <a:schemeClr val="accent1"/>
+          </a:lnRef>
+          <a:fillRef idx="3">
+            <a:schemeClr val="accent1"/>
+          </a:fillRef>
+          <a:effectRef idx="2">
+            <a:schemeClr val="accent1"/>
+          </a:effectRef>
+          <a:fontRef idx="minor">
+            <a:schemeClr val="lt1"/>
+          </a:fontRef>
+        </p:style>
+        <p:txBody>
+          <a:bodyPr rtlCol="0" anchor="ctr"/>
+          <a:lstStyle/>
+          <a:p>
+            <a:pPr algn="ctr"/>
+          </a:p>
+        </p:txBody>
+      </p:sp>
+      <p:sp>
+        <p:nvSpPr>
+          <p:cNvPr id="8" name="TextBox 7"/>
+          <p:cNvSpPr txBox="1"/>
+          <p:nvPr/>
+        </p:nvSpPr>
+        <p:spPr>
+          <a:xfrm>
+            <a:off x="777240" y="5632704"/>
+            <a:ext cx="5120640" cy="658368"/>
+          </a:xfrm>
+          <a:prstGeom prst="rect">
+            <a:avLst/>
+          </a:prstGeom>
+          <a:noFill/>
+        </p:spPr>
+        <p:txBody>
+          <a:bodyPr wrap="square" anchor="t">
+            <a:spAutoFit/>
+          </a:bodyPr>
+          <a:lstStyle/>
+          <a:p>
+            <a:pPr algn="l">
+              <a:spcAft>
+                <a:spcPts val="400"/>
+              </a:spcAft>
+            </a:pPr>
+            <a:r>
+              <a:rPr sz="1050" b="1" i="0">
+                <a:solidFill>
+                  <a:srgbClr val="2F74C0"/>
+                </a:solidFill>
+                <a:latin typeface="Segoe UI"/>
+              </a:rPr>
+              <a:t>⚙ NASIL ÇALIŞIR</a:t>
+            </a:r>
+          </a:p>
+          <a:p>
+            <a:pPr algn="l">
+              <a:spcAft>
+                <a:spcPts val="400"/>
+              </a:spcAft>
+            </a:pPr>
+            <a:r>
+              <a:rPr sz="1300" b="1" i="0">
+                <a:solidFill>
+                  <a:srgbClr val="1F3B57"/>
+                </a:solidFill>
+                <a:latin typeface="Segoe UI"/>
+              </a:rPr>
+              <a:t>Pencere kayar, frekanslar ölçülür</a:t>
+            </a:r>
+          </a:p>
+        </p:txBody>
+      </p:sp>
+      <p:sp>
+        <p:nvSpPr>
+          <p:cNvPr id="9" name="Rounded Rectangle 8"/>
+          <p:cNvSpPr/>
+          <p:nvPr/>
+        </p:nvSpPr>
+        <p:spPr>
+          <a:xfrm>
+            <a:off x="6199632" y="5577840"/>
+            <a:ext cx="5440680" cy="777240"/>
+          </a:xfrm>
+          <a:prstGeom prst="roundRect">
+            <a:avLst>
+              <a:gd name="adj" fmla="val 8000"/>
+            </a:avLst>
+          </a:prstGeom>
+          <a:solidFill>
+            <a:srgbClr val="E9F6EF"/>
+          </a:solidFill>
+          <a:ln>
+            <a:noFill/>
+          </a:ln>
+          <a:effectLst/>
+        </p:spPr>
+        <p:style>
+          <a:lnRef idx="1">
+            <a:schemeClr val="accent1"/>
+          </a:lnRef>
+          <a:fillRef idx="3">
+            <a:schemeClr val="accent1"/>
+          </a:fillRef>
+          <a:effectRef idx="2">
+            <a:schemeClr val="accent1"/>
+          </a:effectRef>
+          <a:fontRef idx="minor">
+            <a:schemeClr val="lt1"/>
+          </a:fontRef>
+        </p:style>
+        <p:txBody>
+          <a:bodyPr rtlCol="0" anchor="ctr"/>
+          <a:lstStyle/>
+          <a:p>
+            <a:pPr algn="ctr"/>
+          </a:p>
+        </p:txBody>
+      </p:sp>
+      <p:sp>
+        <p:nvSpPr>
+          <p:cNvPr id="10" name="Rectangle 9"/>
+          <p:cNvSpPr/>
+          <p:nvPr/>
+        </p:nvSpPr>
+        <p:spPr>
+          <a:xfrm>
+            <a:off x="6199632" y="5577840"/>
+            <a:ext cx="82296" cy="777240"/>
+          </a:xfrm>
+          <a:prstGeom prst="rect">
+            <a:avLst/>
+          </a:prstGeom>
+          <a:solidFill>
+            <a:srgbClr val="1F7A4D"/>
+          </a:solidFill>
+          <a:ln>
+            <a:noFill/>
+          </a:ln>
+          <a:effectLst/>
+        </p:spPr>
+        <p:style>
+          <a:lnRef idx="1">
+            <a:schemeClr val="accent1"/>
+          </a:lnRef>
+          <a:fillRef idx="3">
+            <a:schemeClr val="accent1"/>
+          </a:fillRef>
+          <a:effectRef idx="2">
+            <a:schemeClr val="accent1"/>
+          </a:effectRef>
+          <a:fontRef idx="minor">
+            <a:schemeClr val="lt1"/>
+          </a:fontRef>
+        </p:style>
+        <p:txBody>
+          <a:bodyPr rtlCol="0" anchor="ctr"/>
+          <a:lstStyle/>
+          <a:p>
+            <a:pPr algn="ctr"/>
+          </a:p>
+        </p:txBody>
+      </p:sp>
+      <p:sp>
+        <p:nvSpPr>
+          <p:cNvPr id="11" name="TextBox 10"/>
+          <p:cNvSpPr txBox="1"/>
+          <p:nvPr/>
+        </p:nvSpPr>
+        <p:spPr>
+          <a:xfrm>
+            <a:off x="6428232" y="5632704"/>
+            <a:ext cx="5120640" cy="658368"/>
+          </a:xfrm>
+          <a:prstGeom prst="rect">
+            <a:avLst/>
+          </a:prstGeom>
+          <a:noFill/>
+        </p:spPr>
+        <p:txBody>
+          <a:bodyPr wrap="square" anchor="t">
+            <a:spAutoFit/>
+          </a:bodyPr>
+          <a:lstStyle/>
+          <a:p>
+            <a:pPr algn="l">
+              <a:spcAft>
+                <a:spcPts val="400"/>
+              </a:spcAft>
+            </a:pPr>
+            <a:r>
+              <a:rPr sz="1050" b="1" i="0">
+                <a:solidFill>
+                  <a:srgbClr val="1F7A4D"/>
+                </a:solidFill>
+                <a:latin typeface="Segoe UI"/>
+              </a:rPr>
+              <a:t>🎯 PROJEDEKİ ROLÜ</a:t>
+            </a:r>
+          </a:p>
+          <a:p>
+            <a:pPr algn="l">
+              <a:spcAft>
+                <a:spcPts val="400"/>
+              </a:spcAft>
+            </a:pPr>
+            <a:r>
+              <a:rPr sz="1300" b="1" i="0">
+                <a:solidFill>
+                  <a:srgbClr val="1F3B57"/>
+                </a:solidFill>
+                <a:latin typeface="Segoe UI"/>
+              </a:rPr>
+              <a:t>CNN'in girdisi: 64×128 resim</a:t>
+            </a:r>
+          </a:p>
+        </p:txBody>
+      </p:sp>
+      <p:sp>
+        <p:nvSpPr>
+          <p:cNvPr id="12" name="Rectangle 11"/>
           <p:cNvSpPr/>
           <p:nvPr/>
         </p:nvSpPr>
@@ -18441,7 +21051,7 @@
       </p:sp>
       <p:sp>
         <p:nvSpPr>
-          <p:cNvPr id="7" name="TextBox 6"/>
+          <p:cNvPr id="13" name="TextBox 12"/>
           <p:cNvSpPr txBox="1"/>
           <p:nvPr/>
         </p:nvSpPr>
@@ -18480,7 +21090,7 @@
       </p:sp>
       <p:sp>
         <p:nvSpPr>
-          <p:cNvPr id="8" name="TextBox 7"/>
+          <p:cNvPr id="14" name="TextBox 13"/>
           <p:cNvSpPr txBox="1"/>
           <p:nvPr/>
         </p:nvSpPr>
@@ -18704,7 +21314,297 @@
       </p:pic>
       <p:sp>
         <p:nvSpPr>
-          <p:cNvPr id="6" name="Rectangle 5"/>
+          <p:cNvPr id="6" name="Rounded Rectangle 5"/>
+          <p:cNvSpPr/>
+          <p:nvPr/>
+        </p:nvSpPr>
+        <p:spPr>
+          <a:xfrm>
+            <a:off x="548640" y="5577840"/>
+            <a:ext cx="5440680" cy="777240"/>
+          </a:xfrm>
+          <a:prstGeom prst="roundRect">
+            <a:avLst>
+              <a:gd name="adj" fmla="val 8000"/>
+            </a:avLst>
+          </a:prstGeom>
+          <a:solidFill>
+            <a:srgbClr val="E8F1FA"/>
+          </a:solidFill>
+          <a:ln>
+            <a:noFill/>
+          </a:ln>
+          <a:effectLst/>
+        </p:spPr>
+        <p:style>
+          <a:lnRef idx="1">
+            <a:schemeClr val="accent1"/>
+          </a:lnRef>
+          <a:fillRef idx="3">
+            <a:schemeClr val="accent1"/>
+          </a:fillRef>
+          <a:effectRef idx="2">
+            <a:schemeClr val="accent1"/>
+          </a:effectRef>
+          <a:fontRef idx="minor">
+            <a:schemeClr val="lt1"/>
+          </a:fontRef>
+        </p:style>
+        <p:txBody>
+          <a:bodyPr rtlCol="0" anchor="ctr"/>
+          <a:lstStyle/>
+          <a:p>
+            <a:pPr algn="ctr"/>
+          </a:p>
+        </p:txBody>
+      </p:sp>
+      <p:sp>
+        <p:nvSpPr>
+          <p:cNvPr id="7" name="Rectangle 6"/>
+          <p:cNvSpPr/>
+          <p:nvPr/>
+        </p:nvSpPr>
+        <p:spPr>
+          <a:xfrm>
+            <a:off x="548640" y="5577840"/>
+            <a:ext cx="82296" cy="777240"/>
+          </a:xfrm>
+          <a:prstGeom prst="rect">
+            <a:avLst/>
+          </a:prstGeom>
+          <a:solidFill>
+            <a:srgbClr val="2F74C0"/>
+          </a:solidFill>
+          <a:ln>
+            <a:noFill/>
+          </a:ln>
+          <a:effectLst/>
+        </p:spPr>
+        <p:style>
+          <a:lnRef idx="1">
+            <a:schemeClr val="accent1"/>
+          </a:lnRef>
+          <a:fillRef idx="3">
+            <a:schemeClr val="accent1"/>
+          </a:fillRef>
+          <a:effectRef idx="2">
+            <a:schemeClr val="accent1"/>
+          </a:effectRef>
+          <a:fontRef idx="minor">
+            <a:schemeClr val="lt1"/>
+          </a:fontRef>
+        </p:style>
+        <p:txBody>
+          <a:bodyPr rtlCol="0" anchor="ctr"/>
+          <a:lstStyle/>
+          <a:p>
+            <a:pPr algn="ctr"/>
+          </a:p>
+        </p:txBody>
+      </p:sp>
+      <p:sp>
+        <p:nvSpPr>
+          <p:cNvPr id="8" name="TextBox 7"/>
+          <p:cNvSpPr txBox="1"/>
+          <p:nvPr/>
+        </p:nvSpPr>
+        <p:spPr>
+          <a:xfrm>
+            <a:off x="777240" y="5632704"/>
+            <a:ext cx="5120640" cy="658368"/>
+          </a:xfrm>
+          <a:prstGeom prst="rect">
+            <a:avLst/>
+          </a:prstGeom>
+          <a:noFill/>
+        </p:spPr>
+        <p:txBody>
+          <a:bodyPr wrap="square" anchor="t">
+            <a:spAutoFit/>
+          </a:bodyPr>
+          <a:lstStyle/>
+          <a:p>
+            <a:pPr algn="l">
+              <a:spcAft>
+                <a:spcPts val="400"/>
+              </a:spcAft>
+            </a:pPr>
+            <a:r>
+              <a:rPr sz="1050" b="1" i="0">
+                <a:solidFill>
+                  <a:srgbClr val="2F74C0"/>
+                </a:solidFill>
+                <a:latin typeface="Segoe UI"/>
+              </a:rPr>
+              <a:t>⚙ NASIL ÇALIŞIR</a:t>
+            </a:r>
+          </a:p>
+          <a:p>
+            <a:pPr algn="l">
+              <a:spcAft>
+                <a:spcPts val="400"/>
+              </a:spcAft>
+            </a:pPr>
+            <a:r>
+              <a:rPr sz="1300" b="1" i="0">
+                <a:solidFill>
+                  <a:srgbClr val="1F3B57"/>
+                </a:solidFill>
+                <a:latin typeface="Segoe UI"/>
+              </a:rPr>
+              <a:t>Filtre gezer: çarp + topla</a:t>
+            </a:r>
+          </a:p>
+        </p:txBody>
+      </p:sp>
+      <p:sp>
+        <p:nvSpPr>
+          <p:cNvPr id="9" name="Rounded Rectangle 8"/>
+          <p:cNvSpPr/>
+          <p:nvPr/>
+        </p:nvSpPr>
+        <p:spPr>
+          <a:xfrm>
+            <a:off x="6199632" y="5577840"/>
+            <a:ext cx="5440680" cy="777240"/>
+          </a:xfrm>
+          <a:prstGeom prst="roundRect">
+            <a:avLst>
+              <a:gd name="adj" fmla="val 8000"/>
+            </a:avLst>
+          </a:prstGeom>
+          <a:solidFill>
+            <a:srgbClr val="E9F6EF"/>
+          </a:solidFill>
+          <a:ln>
+            <a:noFill/>
+          </a:ln>
+          <a:effectLst/>
+        </p:spPr>
+        <p:style>
+          <a:lnRef idx="1">
+            <a:schemeClr val="accent1"/>
+          </a:lnRef>
+          <a:fillRef idx="3">
+            <a:schemeClr val="accent1"/>
+          </a:fillRef>
+          <a:effectRef idx="2">
+            <a:schemeClr val="accent1"/>
+          </a:effectRef>
+          <a:fontRef idx="minor">
+            <a:schemeClr val="lt1"/>
+          </a:fontRef>
+        </p:style>
+        <p:txBody>
+          <a:bodyPr rtlCol="0" anchor="ctr"/>
+          <a:lstStyle/>
+          <a:p>
+            <a:pPr algn="ctr"/>
+          </a:p>
+        </p:txBody>
+      </p:sp>
+      <p:sp>
+        <p:nvSpPr>
+          <p:cNvPr id="10" name="Rectangle 9"/>
+          <p:cNvSpPr/>
+          <p:nvPr/>
+        </p:nvSpPr>
+        <p:spPr>
+          <a:xfrm>
+            <a:off x="6199632" y="5577840"/>
+            <a:ext cx="82296" cy="777240"/>
+          </a:xfrm>
+          <a:prstGeom prst="rect">
+            <a:avLst/>
+          </a:prstGeom>
+          <a:solidFill>
+            <a:srgbClr val="1F7A4D"/>
+          </a:solidFill>
+          <a:ln>
+            <a:noFill/>
+          </a:ln>
+          <a:effectLst/>
+        </p:spPr>
+        <p:style>
+          <a:lnRef idx="1">
+            <a:schemeClr val="accent1"/>
+          </a:lnRef>
+          <a:fillRef idx="3">
+            <a:schemeClr val="accent1"/>
+          </a:fillRef>
+          <a:effectRef idx="2">
+            <a:schemeClr val="accent1"/>
+          </a:effectRef>
+          <a:fontRef idx="minor">
+            <a:schemeClr val="lt1"/>
+          </a:fontRef>
+        </p:style>
+        <p:txBody>
+          <a:bodyPr rtlCol="0" anchor="ctr"/>
+          <a:lstStyle/>
+          <a:p>
+            <a:pPr algn="ctr"/>
+          </a:p>
+        </p:txBody>
+      </p:sp>
+      <p:sp>
+        <p:nvSpPr>
+          <p:cNvPr id="11" name="TextBox 10"/>
+          <p:cNvSpPr txBox="1"/>
+          <p:nvPr/>
+        </p:nvSpPr>
+        <p:spPr>
+          <a:xfrm>
+            <a:off x="6428232" y="5632704"/>
+            <a:ext cx="5120640" cy="658368"/>
+          </a:xfrm>
+          <a:prstGeom prst="rect">
+            <a:avLst/>
+          </a:prstGeom>
+          <a:noFill/>
+        </p:spPr>
+        <p:txBody>
+          <a:bodyPr wrap="square" anchor="t">
+            <a:spAutoFit/>
+          </a:bodyPr>
+          <a:lstStyle/>
+          <a:p>
+            <a:pPr algn="l">
+              <a:spcAft>
+                <a:spcPts val="400"/>
+              </a:spcAft>
+            </a:pPr>
+            <a:r>
+              <a:rPr sz="1050" b="1" i="0">
+                <a:solidFill>
+                  <a:srgbClr val="1F7A4D"/>
+                </a:solidFill>
+                <a:latin typeface="Segoe UI"/>
+              </a:rPr>
+              <a:t>🎯 PROJEDEKİ ROLÜ</a:t>
+            </a:r>
+          </a:p>
+          <a:p>
+            <a:pPr algn="l">
+              <a:spcAft>
+                <a:spcPts val="400"/>
+              </a:spcAft>
+            </a:pPr>
+            <a:r>
+              <a:rPr sz="1300" b="1" i="0">
+                <a:solidFill>
+                  <a:srgbClr val="1F3B57"/>
+                </a:solidFill>
+                <a:latin typeface="Segoe UI"/>
+              </a:rPr>
+              <a:t>Duygu desenlerini bulan dedektör (öğrenilir)</a:t>
+            </a:r>
+          </a:p>
+        </p:txBody>
+      </p:sp>
+      <p:sp>
+        <p:nvSpPr>
+          <p:cNvPr id="12" name="Rectangle 11"/>
           <p:cNvSpPr/>
           <p:nvPr/>
         </p:nvSpPr>
@@ -18748,7 +21648,7 @@
       </p:sp>
       <p:sp>
         <p:nvSpPr>
-          <p:cNvPr id="7" name="TextBox 6"/>
+          <p:cNvPr id="13" name="TextBox 12"/>
           <p:cNvSpPr txBox="1"/>
           <p:nvPr/>
         </p:nvSpPr>
@@ -18787,7 +21687,7 @@
       </p:sp>
       <p:sp>
         <p:nvSpPr>
-          <p:cNvPr id="8" name="TextBox 7"/>
+          <p:cNvPr id="14" name="TextBox 13"/>
           <p:cNvSpPr txBox="1"/>
           <p:nvPr/>
         </p:nvSpPr>

</xml_diff>